<commit_message>
Vault backup: PI-3 certification stories/dependencies + ADO PI2.6 reconciliation
- Add SAFe stories + dependencies for all 4 Certify features:
  Computers (1517029), Servers (1517032), Databases (1517037), Network Devices (1517040)
  plus Word-doc renderer (build_cert_feature_docs.py) and generated .docx set
- Reconcile to ADO PI2.6 board (as-of 2026-07-28):
  audit spikes 1480114 + 1480112 CLOSED; env spike created (1526856);
  Oracle DB credential issue (1520824); completeness stories CP-0..CP-4 real IDs
  (1526841/1520415/1520424/1520425/1520414); 3.1 features -> Defining
- Update PI-3 tracking, objectives, data-cert breakdown, CMDB Health stories,
  server-environment spike, and index pointers
- Includes other pending vault changes (full backup)

Co-Authored-By: Claude Opus 4.8 <noreply@anthropic.com>
</commit_message>
<xml_diff>
--- a/Workspaces/Work/Projects/PPL CMDB-CSDM/Leadership-Status/2026-07-08.pptx
+++ b/Workspaces/Work/Projects/PPL CMDB-CSDM/Leadership-Status/2026-07-08.pptx
@@ -5,21 +5,21 @@
     <p:sldMasterId id="2147483648" r:id="rId1"/>
   </p:sldMasterIdLst>
   <p:sldIdLst>
-    <p:sldId id="256" r:id="rId7"/>
-    <p:sldId id="257" r:id="rId8"/>
-    <p:sldId id="258" r:id="rId9"/>
-    <p:sldId id="259" r:id="rId10"/>
-    <p:sldId id="260" r:id="rId11"/>
-    <p:sldId id="261" r:id="rId12"/>
-    <p:sldId id="262" r:id="rId13"/>
-    <p:sldId id="263" r:id="rId14"/>
-    <p:sldId id="264" r:id="rId15"/>
-    <p:sldId id="265" r:id="rId16"/>
-    <p:sldId id="266" r:id="rId17"/>
-    <p:sldId id="267" r:id="rId18"/>
-    <p:sldId id="268" r:id="rId19"/>
+    <p:sldId id="256" r:id="rId2"/>
+    <p:sldId id="257" r:id="rId3"/>
+    <p:sldId id="258" r:id="rId4"/>
+    <p:sldId id="259" r:id="rId5"/>
+    <p:sldId id="260" r:id="rId6"/>
+    <p:sldId id="261" r:id="rId7"/>
+    <p:sldId id="262" r:id="rId8"/>
+    <p:sldId id="263" r:id="rId9"/>
+    <p:sldId id="264" r:id="rId10"/>
+    <p:sldId id="265" r:id="rId11"/>
+    <p:sldId id="266" r:id="rId12"/>
+    <p:sldId id="267" r:id="rId13"/>
+    <p:sldId id="268" r:id="rId14"/>
   </p:sldIdLst>
-  <p:sldSz cx="12191695" cy="6858000" type="screen4x3"/>
+  <p:sldSz cx="12192000" cy="6858000"/>
   <p:notesSz cx="6858000" cy="9144000"/>
   <p:defaultTextStyle>
     <a:defPPr>
@@ -116,6 +116,22 @@
       </a:defRPr>
     </a:lvl9pPr>
   </p:defaultTextStyle>
+  <p:extLst>
+    <p:ext uri="{EFAFB233-063F-42B5-8137-9DF3F51BA10A}">
+      <p15:sldGuideLst xmlns:p15="http://schemas.microsoft.com/office/powerpoint/2012/main">
+        <p15:guide id="1" orient="horz" pos="2160">
+          <p15:clr>
+            <a:srgbClr val="A4A3A4"/>
+          </p15:clr>
+        </p15:guide>
+        <p15:guide id="2" pos="2880">
+          <p15:clr>
+            <a:srgbClr val="A4A3A4"/>
+          </p15:clr>
+        </p15:guide>
+      </p15:sldGuideLst>
+    </p:ext>
+  </p:extLst>
 </p:presentation>
 </file>
 
@@ -157,10 +173,9 @@
           <a:lstStyle/>
           <a:p>
             <a:r>
-              <a:rPr lang="en-US" smtClean="0"/>
+              <a:rPr lang="en-US"/>
               <a:t>Click to edit Master title style</a:t>
             </a:r>
-            <a:endParaRPr lang="en-US"/>
           </a:p>
         </p:txBody>
       </p:sp>
@@ -276,10 +291,9 @@
           </a:lstStyle>
           <a:p>
             <a:r>
-              <a:rPr lang="en-US" smtClean="0"/>
+              <a:rPr lang="en-US"/>
               <a:t>Click to edit Master subtitle style</a:t>
             </a:r>
-            <a:endParaRPr lang="en-US"/>
           </a:p>
         </p:txBody>
       </p:sp>
@@ -300,7 +314,7 @@
           <a:p>
             <a:fld id="{5BCAD085-E8A6-8845-BD4E-CB4CCA059FC4}" type="datetimeFigureOut">
               <a:rPr lang="en-US" smtClean="0"/>
-              <a:t>1/27/13</a:t>
+              <a:t>7/8/2026</a:t>
             </a:fld>
             <a:endParaRPr lang="en-US"/>
           </a:p>
@@ -394,10 +408,9 @@
           <a:lstStyle/>
           <a:p>
             <a:r>
-              <a:rPr lang="en-US" smtClean="0"/>
+              <a:rPr lang="en-US"/>
               <a:t>Click to edit Master title style</a:t>
             </a:r>
-            <a:endParaRPr lang="en-US"/>
           </a:p>
         </p:txBody>
       </p:sp>
@@ -418,38 +431,37 @@
           <a:p>
             <a:pPr lvl="0"/>
             <a:r>
-              <a:rPr lang="en-US" smtClean="0"/>
+              <a:rPr lang="en-US"/>
               <a:t>Click to edit Master text styles</a:t>
             </a:r>
           </a:p>
           <a:p>
             <a:pPr lvl="1"/>
             <a:r>
-              <a:rPr lang="en-US" smtClean="0"/>
+              <a:rPr lang="en-US"/>
               <a:t>Second level</a:t>
             </a:r>
           </a:p>
           <a:p>
             <a:pPr lvl="2"/>
             <a:r>
-              <a:rPr lang="en-US" smtClean="0"/>
+              <a:rPr lang="en-US"/>
               <a:t>Third level</a:t>
             </a:r>
           </a:p>
           <a:p>
             <a:pPr lvl="3"/>
             <a:r>
-              <a:rPr lang="en-US" smtClean="0"/>
+              <a:rPr lang="en-US"/>
               <a:t>Fourth level</a:t>
             </a:r>
           </a:p>
           <a:p>
             <a:pPr lvl="4"/>
             <a:r>
-              <a:rPr lang="en-US" smtClean="0"/>
+              <a:rPr lang="en-US"/>
               <a:t>Fifth level</a:t>
             </a:r>
-            <a:endParaRPr lang="en-US"/>
           </a:p>
         </p:txBody>
       </p:sp>
@@ -470,7 +482,7 @@
           <a:p>
             <a:fld id="{5BCAD085-E8A6-8845-BD4E-CB4CCA059FC4}" type="datetimeFigureOut">
               <a:rPr lang="en-US" smtClean="0"/>
-              <a:t>1/27/13</a:t>
+              <a:t>7/8/2026</a:t>
             </a:fld>
             <a:endParaRPr lang="en-US"/>
           </a:p>
@@ -569,10 +581,9 @@
           <a:lstStyle/>
           <a:p>
             <a:r>
-              <a:rPr lang="en-US" smtClean="0"/>
+              <a:rPr lang="en-US"/>
               <a:t>Click to edit Master title style</a:t>
             </a:r>
-            <a:endParaRPr lang="en-US"/>
           </a:p>
         </p:txBody>
       </p:sp>
@@ -598,38 +609,37 @@
           <a:p>
             <a:pPr lvl="0"/>
             <a:r>
-              <a:rPr lang="en-US" smtClean="0"/>
+              <a:rPr lang="en-US"/>
               <a:t>Click to edit Master text styles</a:t>
             </a:r>
           </a:p>
           <a:p>
             <a:pPr lvl="1"/>
             <a:r>
-              <a:rPr lang="en-US" smtClean="0"/>
+              <a:rPr lang="en-US"/>
               <a:t>Second level</a:t>
             </a:r>
           </a:p>
           <a:p>
             <a:pPr lvl="2"/>
             <a:r>
-              <a:rPr lang="en-US" smtClean="0"/>
+              <a:rPr lang="en-US"/>
               <a:t>Third level</a:t>
             </a:r>
           </a:p>
           <a:p>
             <a:pPr lvl="3"/>
             <a:r>
-              <a:rPr lang="en-US" smtClean="0"/>
+              <a:rPr lang="en-US"/>
               <a:t>Fourth level</a:t>
             </a:r>
           </a:p>
           <a:p>
             <a:pPr lvl="4"/>
             <a:r>
-              <a:rPr lang="en-US" smtClean="0"/>
+              <a:rPr lang="en-US"/>
               <a:t>Fifth level</a:t>
             </a:r>
-            <a:endParaRPr lang="en-US"/>
           </a:p>
         </p:txBody>
       </p:sp>
@@ -650,7 +660,7 @@
           <a:p>
             <a:fld id="{5BCAD085-E8A6-8845-BD4E-CB4CCA059FC4}" type="datetimeFigureOut">
               <a:rPr lang="en-US" smtClean="0"/>
-              <a:t>1/27/13</a:t>
+              <a:t>7/8/2026</a:t>
             </a:fld>
             <a:endParaRPr lang="en-US"/>
           </a:p>
@@ -744,10 +754,9 @@
           <a:lstStyle/>
           <a:p>
             <a:r>
-              <a:rPr lang="en-US" smtClean="0"/>
+              <a:rPr lang="en-US"/>
               <a:t>Click to edit Master title style</a:t>
             </a:r>
-            <a:endParaRPr lang="en-US"/>
           </a:p>
         </p:txBody>
       </p:sp>
@@ -768,38 +777,37 @@
           <a:p>
             <a:pPr lvl="0"/>
             <a:r>
-              <a:rPr lang="en-US" smtClean="0"/>
+              <a:rPr lang="en-US"/>
               <a:t>Click to edit Master text styles</a:t>
             </a:r>
           </a:p>
           <a:p>
             <a:pPr lvl="1"/>
             <a:r>
-              <a:rPr lang="en-US" smtClean="0"/>
+              <a:rPr lang="en-US"/>
               <a:t>Second level</a:t>
             </a:r>
           </a:p>
           <a:p>
             <a:pPr lvl="2"/>
             <a:r>
-              <a:rPr lang="en-US" smtClean="0"/>
+              <a:rPr lang="en-US"/>
               <a:t>Third level</a:t>
             </a:r>
           </a:p>
           <a:p>
             <a:pPr lvl="3"/>
             <a:r>
-              <a:rPr lang="en-US" smtClean="0"/>
+              <a:rPr lang="en-US"/>
               <a:t>Fourth level</a:t>
             </a:r>
           </a:p>
           <a:p>
             <a:pPr lvl="4"/>
             <a:r>
-              <a:rPr lang="en-US" smtClean="0"/>
+              <a:rPr lang="en-US"/>
               <a:t>Fifth level</a:t>
             </a:r>
-            <a:endParaRPr lang="en-US"/>
           </a:p>
         </p:txBody>
       </p:sp>
@@ -820,7 +828,7 @@
           <a:p>
             <a:fld id="{5BCAD085-E8A6-8845-BD4E-CB4CCA059FC4}" type="datetimeFigureOut">
               <a:rPr lang="en-US" smtClean="0"/>
-              <a:t>1/27/13</a:t>
+              <a:t>7/8/2026</a:t>
             </a:fld>
             <a:endParaRPr lang="en-US"/>
           </a:p>
@@ -923,10 +931,9 @@
           </a:lstStyle>
           <a:p>
             <a:r>
-              <a:rPr lang="en-US" smtClean="0"/>
+              <a:rPr lang="en-US"/>
               <a:t>Click to edit Master title style</a:t>
             </a:r>
-            <a:endParaRPr lang="en-US"/>
           </a:p>
         </p:txBody>
       </p:sp>
@@ -1043,7 +1050,7 @@
           <a:p>
             <a:pPr lvl="0"/>
             <a:r>
-              <a:rPr lang="en-US" smtClean="0"/>
+              <a:rPr lang="en-US"/>
               <a:t>Click to edit Master text styles</a:t>
             </a:r>
           </a:p>
@@ -1066,7 +1073,7 @@
           <a:p>
             <a:fld id="{5BCAD085-E8A6-8845-BD4E-CB4CCA059FC4}" type="datetimeFigureOut">
               <a:rPr lang="en-US" smtClean="0"/>
-              <a:t>1/27/13</a:t>
+              <a:t>7/8/2026</a:t>
             </a:fld>
             <a:endParaRPr lang="en-US"/>
           </a:p>
@@ -1160,10 +1167,9 @@
           <a:lstStyle/>
           <a:p>
             <a:r>
-              <a:rPr lang="en-US" smtClean="0"/>
+              <a:rPr lang="en-US"/>
               <a:t>Click to edit Master title style</a:t>
             </a:r>
-            <a:endParaRPr lang="en-US"/>
           </a:p>
         </p:txBody>
       </p:sp>
@@ -1217,38 +1223,37 @@
           <a:p>
             <a:pPr lvl="0"/>
             <a:r>
-              <a:rPr lang="en-US" smtClean="0"/>
+              <a:rPr lang="en-US"/>
               <a:t>Click to edit Master text styles</a:t>
             </a:r>
           </a:p>
           <a:p>
             <a:pPr lvl="1"/>
             <a:r>
-              <a:rPr lang="en-US" smtClean="0"/>
+              <a:rPr lang="en-US"/>
               <a:t>Second level</a:t>
             </a:r>
           </a:p>
           <a:p>
             <a:pPr lvl="2"/>
             <a:r>
-              <a:rPr lang="en-US" smtClean="0"/>
+              <a:rPr lang="en-US"/>
               <a:t>Third level</a:t>
             </a:r>
           </a:p>
           <a:p>
             <a:pPr lvl="3"/>
             <a:r>
-              <a:rPr lang="en-US" smtClean="0"/>
+              <a:rPr lang="en-US"/>
               <a:t>Fourth level</a:t>
             </a:r>
           </a:p>
           <a:p>
             <a:pPr lvl="4"/>
             <a:r>
-              <a:rPr lang="en-US" smtClean="0"/>
+              <a:rPr lang="en-US"/>
               <a:t>Fifth level</a:t>
             </a:r>
-            <a:endParaRPr lang="en-US"/>
           </a:p>
         </p:txBody>
       </p:sp>
@@ -1302,38 +1307,37 @@
           <a:p>
             <a:pPr lvl="0"/>
             <a:r>
-              <a:rPr lang="en-US" smtClean="0"/>
+              <a:rPr lang="en-US"/>
               <a:t>Click to edit Master text styles</a:t>
             </a:r>
           </a:p>
           <a:p>
             <a:pPr lvl="1"/>
             <a:r>
-              <a:rPr lang="en-US" smtClean="0"/>
+              <a:rPr lang="en-US"/>
               <a:t>Second level</a:t>
             </a:r>
           </a:p>
           <a:p>
             <a:pPr lvl="2"/>
             <a:r>
-              <a:rPr lang="en-US" smtClean="0"/>
+              <a:rPr lang="en-US"/>
               <a:t>Third level</a:t>
             </a:r>
           </a:p>
           <a:p>
             <a:pPr lvl="3"/>
             <a:r>
-              <a:rPr lang="en-US" smtClean="0"/>
+              <a:rPr lang="en-US"/>
               <a:t>Fourth level</a:t>
             </a:r>
           </a:p>
           <a:p>
             <a:pPr lvl="4"/>
             <a:r>
-              <a:rPr lang="en-US" smtClean="0"/>
+              <a:rPr lang="en-US"/>
               <a:t>Fifth level</a:t>
             </a:r>
-            <a:endParaRPr lang="en-US"/>
           </a:p>
         </p:txBody>
       </p:sp>
@@ -1354,7 +1358,7 @@
           <a:p>
             <a:fld id="{5BCAD085-E8A6-8845-BD4E-CB4CCA059FC4}" type="datetimeFigureOut">
               <a:rPr lang="en-US" smtClean="0"/>
-              <a:t>1/27/13</a:t>
+              <a:t>7/8/2026</a:t>
             </a:fld>
             <a:endParaRPr lang="en-US"/>
           </a:p>
@@ -1452,10 +1456,9 @@
           </a:lstStyle>
           <a:p>
             <a:r>
-              <a:rPr lang="en-US" smtClean="0"/>
+              <a:rPr lang="en-US"/>
               <a:t>Click to edit Master title style</a:t>
             </a:r>
-            <a:endParaRPr lang="en-US"/>
           </a:p>
         </p:txBody>
       </p:sp>
@@ -1518,7 +1521,7 @@
           <a:p>
             <a:pPr lvl="0"/>
             <a:r>
-              <a:rPr lang="en-US" smtClean="0"/>
+              <a:rPr lang="en-US"/>
               <a:t>Click to edit Master text styles</a:t>
             </a:r>
           </a:p>
@@ -1574,38 +1577,37 @@
           <a:p>
             <a:pPr lvl="0"/>
             <a:r>
-              <a:rPr lang="en-US" smtClean="0"/>
+              <a:rPr lang="en-US"/>
               <a:t>Click to edit Master text styles</a:t>
             </a:r>
           </a:p>
           <a:p>
             <a:pPr lvl="1"/>
             <a:r>
-              <a:rPr lang="en-US" smtClean="0"/>
+              <a:rPr lang="en-US"/>
               <a:t>Second level</a:t>
             </a:r>
           </a:p>
           <a:p>
             <a:pPr lvl="2"/>
             <a:r>
-              <a:rPr lang="en-US" smtClean="0"/>
+              <a:rPr lang="en-US"/>
               <a:t>Third level</a:t>
             </a:r>
           </a:p>
           <a:p>
             <a:pPr lvl="3"/>
             <a:r>
-              <a:rPr lang="en-US" smtClean="0"/>
+              <a:rPr lang="en-US"/>
               <a:t>Fourth level</a:t>
             </a:r>
           </a:p>
           <a:p>
             <a:pPr lvl="4"/>
             <a:r>
-              <a:rPr lang="en-US" smtClean="0"/>
+              <a:rPr lang="en-US"/>
               <a:t>Fifth level</a:t>
             </a:r>
-            <a:endParaRPr lang="en-US"/>
           </a:p>
         </p:txBody>
       </p:sp>
@@ -1668,7 +1670,7 @@
           <a:p>
             <a:pPr lvl="0"/>
             <a:r>
-              <a:rPr lang="en-US" smtClean="0"/>
+              <a:rPr lang="en-US"/>
               <a:t>Click to edit Master text styles</a:t>
             </a:r>
           </a:p>
@@ -1724,38 +1726,37 @@
           <a:p>
             <a:pPr lvl="0"/>
             <a:r>
-              <a:rPr lang="en-US" smtClean="0"/>
+              <a:rPr lang="en-US"/>
               <a:t>Click to edit Master text styles</a:t>
             </a:r>
           </a:p>
           <a:p>
             <a:pPr lvl="1"/>
             <a:r>
-              <a:rPr lang="en-US" smtClean="0"/>
+              <a:rPr lang="en-US"/>
               <a:t>Second level</a:t>
             </a:r>
           </a:p>
           <a:p>
             <a:pPr lvl="2"/>
             <a:r>
-              <a:rPr lang="en-US" smtClean="0"/>
+              <a:rPr lang="en-US"/>
               <a:t>Third level</a:t>
             </a:r>
           </a:p>
           <a:p>
             <a:pPr lvl="3"/>
             <a:r>
-              <a:rPr lang="en-US" smtClean="0"/>
+              <a:rPr lang="en-US"/>
               <a:t>Fourth level</a:t>
             </a:r>
           </a:p>
           <a:p>
             <a:pPr lvl="4"/>
             <a:r>
-              <a:rPr lang="en-US" smtClean="0"/>
+              <a:rPr lang="en-US"/>
               <a:t>Fifth level</a:t>
             </a:r>
-            <a:endParaRPr lang="en-US"/>
           </a:p>
         </p:txBody>
       </p:sp>
@@ -1776,7 +1777,7 @@
           <a:p>
             <a:fld id="{5BCAD085-E8A6-8845-BD4E-CB4CCA059FC4}" type="datetimeFigureOut">
               <a:rPr lang="en-US" smtClean="0"/>
-              <a:t>1/27/13</a:t>
+              <a:t>7/8/2026</a:t>
             </a:fld>
             <a:endParaRPr lang="en-US"/>
           </a:p>
@@ -1870,10 +1871,9 @@
           <a:lstStyle/>
           <a:p>
             <a:r>
-              <a:rPr lang="en-US" smtClean="0"/>
+              <a:rPr lang="en-US"/>
               <a:t>Click to edit Master title style</a:t>
             </a:r>
-            <a:endParaRPr lang="en-US"/>
           </a:p>
         </p:txBody>
       </p:sp>
@@ -1894,7 +1894,7 @@
           <a:p>
             <a:fld id="{5BCAD085-E8A6-8845-BD4E-CB4CCA059FC4}" type="datetimeFigureOut">
               <a:rPr lang="en-US" smtClean="0"/>
-              <a:t>1/27/13</a:t>
+              <a:t>7/8/2026</a:t>
             </a:fld>
             <a:endParaRPr lang="en-US"/>
           </a:p>
@@ -1989,7 +1989,7 @@
           <a:p>
             <a:fld id="{5BCAD085-E8A6-8845-BD4E-CB4CCA059FC4}" type="datetimeFigureOut">
               <a:rPr lang="en-US" smtClean="0"/>
-              <a:t>1/27/13</a:t>
+              <a:t>7/8/2026</a:t>
             </a:fld>
             <a:endParaRPr lang="en-US"/>
           </a:p>
@@ -2092,10 +2092,9 @@
           </a:lstStyle>
           <a:p>
             <a:r>
-              <a:rPr lang="en-US" smtClean="0"/>
+              <a:rPr lang="en-US"/>
               <a:t>Click to edit Master title style</a:t>
             </a:r>
-            <a:endParaRPr lang="en-US"/>
           </a:p>
         </p:txBody>
       </p:sp>
@@ -2149,38 +2148,37 @@
           <a:p>
             <a:pPr lvl="0"/>
             <a:r>
-              <a:rPr lang="en-US" smtClean="0"/>
+              <a:rPr lang="en-US"/>
               <a:t>Click to edit Master text styles</a:t>
             </a:r>
           </a:p>
           <a:p>
             <a:pPr lvl="1"/>
             <a:r>
-              <a:rPr lang="en-US" smtClean="0"/>
+              <a:rPr lang="en-US"/>
               <a:t>Second level</a:t>
             </a:r>
           </a:p>
           <a:p>
             <a:pPr lvl="2"/>
             <a:r>
-              <a:rPr lang="en-US" smtClean="0"/>
+              <a:rPr lang="en-US"/>
               <a:t>Third level</a:t>
             </a:r>
           </a:p>
           <a:p>
             <a:pPr lvl="3"/>
             <a:r>
-              <a:rPr lang="en-US" smtClean="0"/>
+              <a:rPr lang="en-US"/>
               <a:t>Fourth level</a:t>
             </a:r>
           </a:p>
           <a:p>
             <a:pPr lvl="4"/>
             <a:r>
-              <a:rPr lang="en-US" smtClean="0"/>
+              <a:rPr lang="en-US"/>
               <a:t>Fifth level</a:t>
             </a:r>
-            <a:endParaRPr lang="en-US"/>
           </a:p>
         </p:txBody>
       </p:sp>
@@ -2243,7 +2241,7 @@
           <a:p>
             <a:pPr lvl="0"/>
             <a:r>
-              <a:rPr lang="en-US" smtClean="0"/>
+              <a:rPr lang="en-US"/>
               <a:t>Click to edit Master text styles</a:t>
             </a:r>
           </a:p>
@@ -2266,7 +2264,7 @@
           <a:p>
             <a:fld id="{5BCAD085-E8A6-8845-BD4E-CB4CCA059FC4}" type="datetimeFigureOut">
               <a:rPr lang="en-US" smtClean="0"/>
-              <a:t>1/27/13</a:t>
+              <a:t>7/8/2026</a:t>
             </a:fld>
             <a:endParaRPr lang="en-US"/>
           </a:p>
@@ -2369,10 +2367,9 @@
           </a:lstStyle>
           <a:p>
             <a:r>
-              <a:rPr lang="en-US" smtClean="0"/>
+              <a:rPr lang="en-US"/>
               <a:t>Click to edit Master title style</a:t>
             </a:r>
-            <a:endParaRPr lang="en-US"/>
           </a:p>
         </p:txBody>
       </p:sp>
@@ -2496,7 +2493,7 @@
           <a:p>
             <a:pPr lvl="0"/>
             <a:r>
-              <a:rPr lang="en-US" smtClean="0"/>
+              <a:rPr lang="en-US"/>
               <a:t>Click to edit Master text styles</a:t>
             </a:r>
           </a:p>
@@ -2519,7 +2516,7 @@
           <a:p>
             <a:fld id="{5BCAD085-E8A6-8845-BD4E-CB4CCA059FC4}" type="datetimeFigureOut">
               <a:rPr lang="en-US" smtClean="0"/>
-              <a:t>1/27/13</a:t>
+              <a:t>7/8/2026</a:t>
             </a:fld>
             <a:endParaRPr lang="en-US"/>
           </a:p>
@@ -2628,10 +2625,9 @@
           <a:lstStyle/>
           <a:p>
             <a:r>
-              <a:rPr lang="en-US" smtClean="0"/>
+              <a:rPr lang="en-US"/>
               <a:t>Click to edit Master title style</a:t>
             </a:r>
-            <a:endParaRPr lang="en-US"/>
           </a:p>
         </p:txBody>
       </p:sp>
@@ -2662,38 +2658,37 @@
           <a:p>
             <a:pPr lvl="0"/>
             <a:r>
-              <a:rPr lang="en-US" smtClean="0"/>
+              <a:rPr lang="en-US"/>
               <a:t>Click to edit Master text styles</a:t>
             </a:r>
           </a:p>
           <a:p>
             <a:pPr lvl="1"/>
             <a:r>
-              <a:rPr lang="en-US" smtClean="0"/>
+              <a:rPr lang="en-US"/>
               <a:t>Second level</a:t>
             </a:r>
           </a:p>
           <a:p>
             <a:pPr lvl="2"/>
             <a:r>
-              <a:rPr lang="en-US" smtClean="0"/>
+              <a:rPr lang="en-US"/>
               <a:t>Third level</a:t>
             </a:r>
           </a:p>
           <a:p>
             <a:pPr lvl="3"/>
             <a:r>
-              <a:rPr lang="en-US" smtClean="0"/>
+              <a:rPr lang="en-US"/>
               <a:t>Fourth level</a:t>
             </a:r>
           </a:p>
           <a:p>
             <a:pPr lvl="4"/>
             <a:r>
-              <a:rPr lang="en-US" smtClean="0"/>
+              <a:rPr lang="en-US"/>
               <a:t>Fifth level</a:t>
             </a:r>
-            <a:endParaRPr lang="en-US"/>
           </a:p>
         </p:txBody>
       </p:sp>
@@ -2732,7 +2727,7 @@
           <a:p>
             <a:fld id="{5BCAD085-E8A6-8845-BD4E-CB4CCA059FC4}" type="datetimeFigureOut">
               <a:rPr lang="en-US" smtClean="0"/>
-              <a:t>1/27/13</a:t>
+              <a:t>7/8/2026</a:t>
             </a:fld>
             <a:endParaRPr lang="en-US"/>
           </a:p>
@@ -3091,7 +3086,7 @@
 </file>
 
 <file path=ppt/slides/slide1.xml><?xml version="1.0" encoding="utf-8"?>
-<p:sld xmlns:a="http://schemas.openxmlformats.org/drawingml/2006/main" xmlns:p="http://schemas.openxmlformats.org/presentationml/2006/main" xmlns:r="http://schemas.openxmlformats.org/officeDocument/2006/relationships">
+<p:sld xmlns:a="http://schemas.openxmlformats.org/drawingml/2006/main" xmlns:r="http://schemas.openxmlformats.org/officeDocument/2006/relationships" xmlns:p="http://schemas.openxmlformats.org/presentationml/2006/main">
   <p:cSld>
     <p:spTree>
       <p:nvGrpSpPr>
@@ -3099,7 +3094,14 @@
         <p:cNvGrpSpPr/>
         <p:nvPr/>
       </p:nvGrpSpPr>
-      <p:grpSpPr/>
+      <p:grpSpPr>
+        <a:xfrm>
+          <a:off x="0" y="0"/>
+          <a:ext cx="0" cy="0"/>
+          <a:chOff x="0" y="0"/>
+          <a:chExt cx="0" cy="0"/>
+        </a:xfrm>
+      </p:grpSpPr>
       <p:sp>
         <p:nvSpPr>
           <p:cNvPr id="2" name="Rectangle 1"/>
@@ -3141,6 +3143,7 @@
           <a:lstStyle/>
           <a:p>
             <a:pPr algn="ctr"/>
+            <a:endParaRPr/>
           </a:p>
         </p:txBody>
       </p:sp>
@@ -3185,6 +3188,7 @@
           <a:lstStyle/>
           <a:p>
             <a:pPr algn="ctr"/>
+            <a:endParaRPr/>
           </a:p>
         </p:txBody>
       </p:sp>
@@ -3205,7 +3209,7 @@
           <a:noFill/>
         </p:spPr>
         <p:txBody>
-          <a:bodyPr wrap="square" anchor="t" lIns="50800" rIns="50800" tIns="25400" bIns="25400">
+          <a:bodyPr wrap="square" lIns="50800" tIns="25400" rIns="50800" bIns="25400" anchor="t">
             <a:spAutoFit/>
           </a:bodyPr>
           <a:lstStyle/>
@@ -3240,7 +3244,7 @@
           <a:noFill/>
         </p:spPr>
         <p:txBody>
-          <a:bodyPr wrap="square" anchor="t" lIns="50800" rIns="50800" tIns="25400" bIns="25400">
+          <a:bodyPr wrap="square" lIns="50800" tIns="25400" rIns="50800" bIns="25400" anchor="t">
             <a:spAutoFit/>
           </a:bodyPr>
           <a:lstStyle/>
@@ -3267,22 +3271,22 @@
         <p:spPr>
           <a:xfrm>
             <a:off x="749808" y="4343400"/>
-            <a:ext cx="10698480" cy="1280160"/>
-          </a:xfrm>
-          <a:prstGeom prst="rect">
-            <a:avLst/>
-          </a:prstGeom>
-          <a:noFill/>
-        </p:spPr>
-        <p:txBody>
-          <a:bodyPr wrap="square" anchor="t" lIns="50800" rIns="50800" tIns="25400" bIns="25400">
-            <a:spAutoFit/>
-          </a:bodyPr>
-          <a:lstStyle/>
-          <a:p>
-            <a:pPr algn="l"/>
-            <a:r>
-              <a:rPr sz="1600" b="1" i="0">
+            <a:ext cx="10698480" cy="697627"/>
+          </a:xfrm>
+          <a:prstGeom prst="rect">
+            <a:avLst/>
+          </a:prstGeom>
+          <a:noFill/>
+        </p:spPr>
+        <p:txBody>
+          <a:bodyPr wrap="square" lIns="50800" tIns="25400" rIns="50800" bIns="25400" anchor="t">
+            <a:spAutoFit/>
+          </a:bodyPr>
+          <a:lstStyle/>
+          <a:p>
+            <a:pPr algn="l"/>
+            <a:r>
+              <a:rPr sz="1600" b="1" i="0" dirty="0">
                 <a:solidFill>
                   <a:srgbClr val="FFFFFF"/>
                 </a:solidFill>
@@ -3294,19 +3298,37 @@
           <a:p>
             <a:pPr algn="l"/>
             <a:r>
-              <a:rPr sz="1400" b="0" i="0">
+              <a:rPr sz="1400" b="0" i="0" dirty="0">
                 <a:solidFill>
                   <a:srgbClr val="C9D6E6"/>
                 </a:solidFill>
                 <a:latin typeface="Segoe UI"/>
               </a:rPr>
-              <a:t>Week of July 8, 2026</a:t>
-            </a:r>
-          </a:p>
-          <a:p>
-            <a:pPr algn="l"/>
-            <a:r>
-              <a:rPr sz="1200" b="0" i="0">
+              <a:t>Week of July </a:t>
+            </a:r>
+            <a:r>
+              <a:rPr lang="en-US" sz="1400" b="0" i="0" dirty="0">
+                <a:solidFill>
+                  <a:srgbClr val="C9D6E6"/>
+                </a:solidFill>
+                <a:latin typeface="Segoe UI"/>
+              </a:rPr>
+              <a:t>6</a:t>
+            </a:r>
+            <a:r>
+              <a:rPr sz="1400" b="0" i="0" dirty="0">
+                <a:solidFill>
+                  <a:srgbClr val="C9D6E6"/>
+                </a:solidFill>
+                <a:latin typeface="Segoe UI"/>
+              </a:rPr>
+              <a:t>, 2026</a:t>
+            </a:r>
+          </a:p>
+          <a:p>
+            <a:pPr algn="l"/>
+            <a:r>
+              <a:rPr sz="1200" b="0" i="0" dirty="0">
                 <a:solidFill>
                   <a:srgbClr val="9FB2CC"/>
                 </a:solidFill>
@@ -3326,7 +3348,7 @@
 </file>
 
 <file path=ppt/slides/slide10.xml><?xml version="1.0" encoding="utf-8"?>
-<p:sld xmlns:a="http://schemas.openxmlformats.org/drawingml/2006/main" xmlns:p="http://schemas.openxmlformats.org/presentationml/2006/main" xmlns:r="http://schemas.openxmlformats.org/officeDocument/2006/relationships">
+<p:sld xmlns:a="http://schemas.openxmlformats.org/drawingml/2006/main" xmlns:r="http://schemas.openxmlformats.org/officeDocument/2006/relationships" xmlns:p="http://schemas.openxmlformats.org/presentationml/2006/main">
   <p:cSld>
     <p:spTree>
       <p:nvGrpSpPr>
@@ -3334,7 +3356,14 @@
         <p:cNvGrpSpPr/>
         <p:nvPr/>
       </p:nvGrpSpPr>
-      <p:grpSpPr/>
+      <p:grpSpPr>
+        <a:xfrm>
+          <a:off x="0" y="0"/>
+          <a:ext cx="0" cy="0"/>
+          <a:chOff x="0" y="0"/>
+          <a:chExt cx="0" cy="0"/>
+        </a:xfrm>
+      </p:grpSpPr>
       <p:sp>
         <p:nvSpPr>
           <p:cNvPr id="2" name="Rectangle 1"/>
@@ -3376,6 +3405,7 @@
           <a:lstStyle/>
           <a:p>
             <a:pPr algn="ctr"/>
+            <a:endParaRPr/>
           </a:p>
         </p:txBody>
       </p:sp>
@@ -3420,6 +3450,7 @@
           <a:lstStyle/>
           <a:p>
             <a:pPr algn="ctr"/>
+            <a:endParaRPr/>
           </a:p>
         </p:txBody>
       </p:sp>
@@ -3440,7 +3471,7 @@
           <a:noFill/>
         </p:spPr>
         <p:txBody>
-          <a:bodyPr wrap="square" anchor="ctr" lIns="50800" rIns="50800" tIns="25400" bIns="25400">
+          <a:bodyPr wrap="square" lIns="50800" tIns="25400" rIns="50800" bIns="25400" anchor="ctr">
             <a:spAutoFit/>
           </a:bodyPr>
           <a:lstStyle/>
@@ -3475,7 +3506,7 @@
           <a:noFill/>
         </p:spPr>
         <p:txBody>
-          <a:bodyPr wrap="square" anchor="ctr" lIns="50800" rIns="50800" tIns="25400" bIns="25400">
+          <a:bodyPr wrap="square" lIns="50800" tIns="25400" rIns="50800" bIns="25400" anchor="ctr">
             <a:spAutoFit/>
           </a:bodyPr>
           <a:lstStyle/>
@@ -3510,7 +3541,7 @@
           <a:noFill/>
         </p:spPr>
         <p:txBody>
-          <a:bodyPr wrap="square" anchor="t" lIns="50800" rIns="50800" tIns="25400" bIns="25400">
+          <a:bodyPr wrap="square" lIns="50800" tIns="25400" rIns="50800" bIns="25400" anchor="t">
             <a:spAutoFit/>
           </a:bodyPr>
           <a:lstStyle/>
@@ -3569,6 +3600,7 @@
           <a:lstStyle/>
           <a:p>
             <a:pPr algn="ctr"/>
+            <a:endParaRPr/>
           </a:p>
         </p:txBody>
       </p:sp>
@@ -3589,7 +3621,7 @@
           <a:noFill/>
         </p:spPr>
         <p:txBody>
-          <a:bodyPr wrap="square" anchor="ctr" lIns="50800" rIns="50800" tIns="25400" bIns="25400">
+          <a:bodyPr wrap="square" lIns="50800" tIns="25400" rIns="50800" bIns="25400" anchor="ctr">
             <a:spAutoFit/>
           </a:bodyPr>
           <a:lstStyle/>
@@ -3648,6 +3680,7 @@
           <a:lstStyle/>
           <a:p>
             <a:pPr algn="ctr"/>
+            <a:endParaRPr/>
           </a:p>
         </p:txBody>
       </p:sp>
@@ -3668,7 +3701,7 @@
           <a:noFill/>
         </p:spPr>
         <p:txBody>
-          <a:bodyPr wrap="square" anchor="ctr" lIns="50800" rIns="50800" tIns="25400" bIns="25400">
+          <a:bodyPr wrap="square" lIns="50800" tIns="25400" rIns="50800" bIns="25400" anchor="ctr">
             <a:spAutoFit/>
           </a:bodyPr>
           <a:lstStyle/>
@@ -3727,6 +3760,7 @@
           <a:lstStyle/>
           <a:p>
             <a:pPr algn="ctr"/>
+            <a:endParaRPr/>
           </a:p>
         </p:txBody>
       </p:sp>
@@ -3747,7 +3781,7 @@
           <a:noFill/>
         </p:spPr>
         <p:txBody>
-          <a:bodyPr wrap="square" anchor="ctr" lIns="50800" rIns="50800" tIns="25400" bIns="25400">
+          <a:bodyPr wrap="square" lIns="50800" tIns="25400" rIns="50800" bIns="25400" anchor="ctr">
             <a:spAutoFit/>
           </a:bodyPr>
           <a:lstStyle/>
@@ -3806,6 +3840,7 @@
           <a:lstStyle/>
           <a:p>
             <a:pPr algn="ctr"/>
+            <a:endParaRPr/>
           </a:p>
         </p:txBody>
       </p:sp>
@@ -3826,7 +3861,7 @@
           <a:noFill/>
         </p:spPr>
         <p:txBody>
-          <a:bodyPr wrap="square" anchor="ctr" lIns="50800" rIns="50800" tIns="25400" bIns="25400">
+          <a:bodyPr wrap="square" lIns="50800" tIns="25400" rIns="50800" bIns="25400" anchor="ctr">
             <a:spAutoFit/>
           </a:bodyPr>
           <a:lstStyle/>
@@ -3885,6 +3920,7 @@
           <a:lstStyle/>
           <a:p>
             <a:pPr algn="ctr"/>
+            <a:endParaRPr/>
           </a:p>
         </p:txBody>
       </p:sp>
@@ -3905,7 +3941,7 @@
           <a:noFill/>
         </p:spPr>
         <p:txBody>
-          <a:bodyPr wrap="square" anchor="ctr" lIns="50800" rIns="50800" tIns="25400" bIns="25400">
+          <a:bodyPr wrap="square" lIns="50800" tIns="25400" rIns="50800" bIns="25400" anchor="ctr">
             <a:spAutoFit/>
           </a:bodyPr>
           <a:lstStyle/>
@@ -3964,6 +4000,7 @@
           <a:lstStyle/>
           <a:p>
             <a:pPr algn="ctr"/>
+            <a:endParaRPr/>
           </a:p>
         </p:txBody>
       </p:sp>
@@ -3984,7 +4021,7 @@
           <a:noFill/>
         </p:spPr>
         <p:txBody>
-          <a:bodyPr wrap="square" anchor="ctr" lIns="50800" rIns="50800" tIns="25400" bIns="25400">
+          <a:bodyPr wrap="square" lIns="50800" tIns="25400" rIns="50800" bIns="25400" anchor="ctr">
             <a:spAutoFit/>
           </a:bodyPr>
           <a:lstStyle/>
@@ -4043,6 +4080,7 @@
           <a:lstStyle/>
           <a:p>
             <a:pPr algn="ctr"/>
+            <a:endParaRPr/>
           </a:p>
         </p:txBody>
       </p:sp>
@@ -4063,7 +4101,7 @@
           <a:noFill/>
         </p:spPr>
         <p:txBody>
-          <a:bodyPr wrap="square" anchor="ctr" lIns="50800" rIns="50800" tIns="25400" bIns="25400">
+          <a:bodyPr wrap="square" lIns="50800" tIns="25400" rIns="50800" bIns="25400" anchor="ctr">
             <a:spAutoFit/>
           </a:bodyPr>
           <a:lstStyle/>
@@ -4122,6 +4160,7 @@
           <a:lstStyle/>
           <a:p>
             <a:pPr algn="ctr"/>
+            <a:endParaRPr/>
           </a:p>
         </p:txBody>
       </p:sp>
@@ -4142,7 +4181,7 @@
           <a:noFill/>
         </p:spPr>
         <p:txBody>
-          <a:bodyPr wrap="square" anchor="ctr" lIns="50800" rIns="50800" tIns="25400" bIns="25400">
+          <a:bodyPr wrap="square" lIns="50800" tIns="25400" rIns="50800" bIns="25400" anchor="ctr">
             <a:spAutoFit/>
           </a:bodyPr>
           <a:lstStyle/>
@@ -4201,6 +4240,7 @@
           <a:lstStyle/>
           <a:p>
             <a:pPr algn="ctr"/>
+            <a:endParaRPr/>
           </a:p>
         </p:txBody>
       </p:sp>
@@ -4221,7 +4261,7 @@
           <a:noFill/>
         </p:spPr>
         <p:txBody>
-          <a:bodyPr wrap="square" anchor="ctr" lIns="50800" rIns="50800" tIns="25400" bIns="25400">
+          <a:bodyPr wrap="square" lIns="50800" tIns="25400" rIns="50800" bIns="25400" anchor="ctr">
             <a:spAutoFit/>
           </a:bodyPr>
           <a:lstStyle/>
@@ -4280,6 +4320,7 @@
           <a:lstStyle/>
           <a:p>
             <a:pPr algn="ctr"/>
+            <a:endParaRPr/>
           </a:p>
         </p:txBody>
       </p:sp>
@@ -4300,7 +4341,7 @@
           <a:noFill/>
         </p:spPr>
         <p:txBody>
-          <a:bodyPr wrap="square" anchor="ctr" lIns="50800" rIns="50800" tIns="25400" bIns="25400">
+          <a:bodyPr wrap="square" lIns="50800" tIns="25400" rIns="50800" bIns="25400" anchor="ctr">
             <a:spAutoFit/>
           </a:bodyPr>
           <a:lstStyle/>
@@ -4359,6 +4400,7 @@
           <a:lstStyle/>
           <a:p>
             <a:pPr algn="ctr"/>
+            <a:endParaRPr/>
           </a:p>
         </p:txBody>
       </p:sp>
@@ -4379,7 +4421,7 @@
           <a:noFill/>
         </p:spPr>
         <p:txBody>
-          <a:bodyPr wrap="square" anchor="ctr" lIns="50800" rIns="50800" tIns="25400" bIns="25400">
+          <a:bodyPr wrap="square" lIns="50800" tIns="25400" rIns="50800" bIns="25400" anchor="ctr">
             <a:spAutoFit/>
           </a:bodyPr>
           <a:lstStyle/>
@@ -4438,6 +4480,7 @@
           <a:lstStyle/>
           <a:p>
             <a:pPr algn="ctr"/>
+            <a:endParaRPr/>
           </a:p>
         </p:txBody>
       </p:sp>
@@ -4458,7 +4501,7 @@
           <a:noFill/>
         </p:spPr>
         <p:txBody>
-          <a:bodyPr wrap="square" anchor="ctr" lIns="50800" rIns="50800" tIns="25400" bIns="25400">
+          <a:bodyPr wrap="square" lIns="50800" tIns="25400" rIns="50800" bIns="25400" anchor="ctr">
             <a:spAutoFit/>
           </a:bodyPr>
           <a:lstStyle/>
@@ -4517,6 +4560,7 @@
           <a:lstStyle/>
           <a:p>
             <a:pPr algn="ctr"/>
+            <a:endParaRPr/>
           </a:p>
         </p:txBody>
       </p:sp>
@@ -4537,7 +4581,7 @@
           <a:noFill/>
         </p:spPr>
         <p:txBody>
-          <a:bodyPr wrap="square" anchor="ctr" lIns="50800" rIns="50800" tIns="25400" bIns="25400">
+          <a:bodyPr wrap="square" lIns="50800" tIns="25400" rIns="50800" bIns="25400" anchor="ctr">
             <a:spAutoFit/>
           </a:bodyPr>
           <a:lstStyle/>
@@ -4596,6 +4640,7 @@
           <a:lstStyle/>
           <a:p>
             <a:pPr algn="ctr"/>
+            <a:endParaRPr/>
           </a:p>
         </p:txBody>
       </p:sp>
@@ -4616,7 +4661,7 @@
           <a:noFill/>
         </p:spPr>
         <p:txBody>
-          <a:bodyPr wrap="square" anchor="ctr" lIns="50800" rIns="50800" tIns="25400" bIns="25400">
+          <a:bodyPr wrap="square" lIns="50800" tIns="25400" rIns="50800" bIns="25400" anchor="ctr">
             <a:spAutoFit/>
           </a:bodyPr>
           <a:lstStyle/>
@@ -4675,6 +4720,7 @@
           <a:lstStyle/>
           <a:p>
             <a:pPr algn="ctr"/>
+            <a:endParaRPr/>
           </a:p>
         </p:txBody>
       </p:sp>
@@ -4695,7 +4741,7 @@
           <a:noFill/>
         </p:spPr>
         <p:txBody>
-          <a:bodyPr wrap="square" anchor="ctr" lIns="50800" rIns="50800" tIns="25400" bIns="25400">
+          <a:bodyPr wrap="square" lIns="50800" tIns="25400" rIns="50800" bIns="25400" anchor="ctr">
             <a:spAutoFit/>
           </a:bodyPr>
           <a:lstStyle/>
@@ -4754,6 +4800,7 @@
           <a:lstStyle/>
           <a:p>
             <a:pPr algn="ctr"/>
+            <a:endParaRPr/>
           </a:p>
         </p:txBody>
       </p:sp>
@@ -4774,7 +4821,7 @@
           <a:noFill/>
         </p:spPr>
         <p:txBody>
-          <a:bodyPr wrap="square" anchor="ctr" lIns="50800" rIns="50800" tIns="25400" bIns="25400">
+          <a:bodyPr wrap="square" lIns="50800" tIns="25400" rIns="50800" bIns="25400" anchor="ctr">
             <a:spAutoFit/>
           </a:bodyPr>
           <a:lstStyle/>
@@ -4801,7 +4848,7 @@
 </file>
 
 <file path=ppt/slides/slide11.xml><?xml version="1.0" encoding="utf-8"?>
-<p:sld xmlns:a="http://schemas.openxmlformats.org/drawingml/2006/main" xmlns:p="http://schemas.openxmlformats.org/presentationml/2006/main" xmlns:r="http://schemas.openxmlformats.org/officeDocument/2006/relationships">
+<p:sld xmlns:a="http://schemas.openxmlformats.org/drawingml/2006/main" xmlns:r="http://schemas.openxmlformats.org/officeDocument/2006/relationships" xmlns:p="http://schemas.openxmlformats.org/presentationml/2006/main">
   <p:cSld>
     <p:spTree>
       <p:nvGrpSpPr>
@@ -4809,7 +4856,14 @@
         <p:cNvGrpSpPr/>
         <p:nvPr/>
       </p:nvGrpSpPr>
-      <p:grpSpPr/>
+      <p:grpSpPr>
+        <a:xfrm>
+          <a:off x="0" y="0"/>
+          <a:ext cx="0" cy="0"/>
+          <a:chOff x="0" y="0"/>
+          <a:chExt cx="0" cy="0"/>
+        </a:xfrm>
+      </p:grpSpPr>
       <p:sp>
         <p:nvSpPr>
           <p:cNvPr id="2" name="Rectangle 1"/>
@@ -4851,6 +4905,7 @@
           <a:lstStyle/>
           <a:p>
             <a:pPr algn="ctr"/>
+            <a:endParaRPr/>
           </a:p>
         </p:txBody>
       </p:sp>
@@ -4895,6 +4950,7 @@
           <a:lstStyle/>
           <a:p>
             <a:pPr algn="ctr"/>
+            <a:endParaRPr/>
           </a:p>
         </p:txBody>
       </p:sp>
@@ -4915,7 +4971,7 @@
           <a:noFill/>
         </p:spPr>
         <p:txBody>
-          <a:bodyPr wrap="square" anchor="ctr" lIns="50800" rIns="50800" tIns="25400" bIns="25400">
+          <a:bodyPr wrap="square" lIns="50800" tIns="25400" rIns="50800" bIns="25400" anchor="ctr">
             <a:spAutoFit/>
           </a:bodyPr>
           <a:lstStyle/>
@@ -4950,7 +5006,7 @@
           <a:noFill/>
         </p:spPr>
         <p:txBody>
-          <a:bodyPr wrap="square" anchor="ctr" lIns="50800" rIns="50800" tIns="25400" bIns="25400">
+          <a:bodyPr wrap="square" lIns="50800" tIns="25400" rIns="50800" bIns="25400" anchor="ctr">
             <a:spAutoFit/>
           </a:bodyPr>
           <a:lstStyle/>
@@ -4985,7 +5041,7 @@
           <a:noFill/>
         </p:spPr>
         <p:txBody>
-          <a:bodyPr wrap="square" anchor="t" lIns="50800" rIns="50800" tIns="25400" bIns="25400">
+          <a:bodyPr wrap="square" lIns="50800" tIns="25400" rIns="50800" bIns="25400" anchor="t">
             <a:spAutoFit/>
           </a:bodyPr>
           <a:lstStyle/>
@@ -5022,10 +5078,34 @@
                 <a:tableStyleId>{5C22544A-7EE6-4342-B048-85BDC9FD1C3A}</a:tableStyleId>
               </a:tblPr>
               <a:tblGrid>
-                <a:gridCol w="2377440"/>
-                <a:gridCol w="1005840"/>
-                <a:gridCol w="4023360"/>
-                <a:gridCol w="3749039"/>
+                <a:gridCol w="2377440">
+                  <a:extLst>
+                    <a:ext uri="{9D8B030D-6E8A-4147-A177-3AD203B41FA5}">
+                      <a16:colId xmlns:a16="http://schemas.microsoft.com/office/drawing/2014/main" val="20000"/>
+                    </a:ext>
+                  </a:extLst>
+                </a:gridCol>
+                <a:gridCol w="1005840">
+                  <a:extLst>
+                    <a:ext uri="{9D8B030D-6E8A-4147-A177-3AD203B41FA5}">
+                      <a16:colId xmlns:a16="http://schemas.microsoft.com/office/drawing/2014/main" val="20001"/>
+                    </a:ext>
+                  </a:extLst>
+                </a:gridCol>
+                <a:gridCol w="4023360">
+                  <a:extLst>
+                    <a:ext uri="{9D8B030D-6E8A-4147-A177-3AD203B41FA5}">
+                      <a16:colId xmlns:a16="http://schemas.microsoft.com/office/drawing/2014/main" val="20002"/>
+                    </a:ext>
+                  </a:extLst>
+                </a:gridCol>
+                <a:gridCol w="3749039">
+                  <a:extLst>
+                    <a:ext uri="{9D8B030D-6E8A-4147-A177-3AD203B41FA5}">
+                      <a16:colId xmlns:a16="http://schemas.microsoft.com/office/drawing/2014/main" val="20003"/>
+                    </a:ext>
+                  </a:extLst>
+                </a:gridCol>
               </a:tblGrid>
               <a:tr h="701040">
                 <a:tc>
@@ -5116,6 +5196,11 @@
                     </a:solidFill>
                   </a:tcPr>
                 </a:tc>
+                <a:extLst>
+                  <a:ext uri="{0D108BD9-81ED-4DB2-BD59-A6C34878D82A}">
+                    <a16:rowId xmlns:a16="http://schemas.microsoft.com/office/drawing/2014/main" val="10000"/>
+                  </a:ext>
+                </a:extLst>
               </a:tr>
               <a:tr h="701040">
                 <a:tc>
@@ -5207,6 +5292,11 @@
                     </a:solidFill>
                   </a:tcPr>
                 </a:tc>
+                <a:extLst>
+                  <a:ext uri="{0D108BD9-81ED-4DB2-BD59-A6C34878D82A}">
+                    <a16:rowId xmlns:a16="http://schemas.microsoft.com/office/drawing/2014/main" val="10001"/>
+                  </a:ext>
+                </a:extLst>
               </a:tr>
               <a:tr h="701040">
                 <a:tc>
@@ -5298,6 +5388,11 @@
                     </a:solidFill>
                   </a:tcPr>
                 </a:tc>
+                <a:extLst>
+                  <a:ext uri="{0D108BD9-81ED-4DB2-BD59-A6C34878D82A}">
+                    <a16:rowId xmlns:a16="http://schemas.microsoft.com/office/drawing/2014/main" val="10002"/>
+                  </a:ext>
+                </a:extLst>
               </a:tr>
               <a:tr h="701040">
                 <a:tc>
@@ -5389,6 +5484,11 @@
                     </a:solidFill>
                   </a:tcPr>
                 </a:tc>
+                <a:extLst>
+                  <a:ext uri="{0D108BD9-81ED-4DB2-BD59-A6C34878D82A}">
+                    <a16:rowId xmlns:a16="http://schemas.microsoft.com/office/drawing/2014/main" val="10003"/>
+                  </a:ext>
+                </a:extLst>
               </a:tr>
               <a:tr h="701040">
                 <a:tc>
@@ -5480,6 +5580,11 @@
                     </a:solidFill>
                   </a:tcPr>
                 </a:tc>
+                <a:extLst>
+                  <a:ext uri="{0D108BD9-81ED-4DB2-BD59-A6C34878D82A}">
+                    <a16:rowId xmlns:a16="http://schemas.microsoft.com/office/drawing/2014/main" val="10004"/>
+                  </a:ext>
+                </a:extLst>
               </a:tr>
               <a:tr h="701040">
                 <a:tc>
@@ -5571,6 +5676,11 @@
                     </a:solidFill>
                   </a:tcPr>
                 </a:tc>
+                <a:extLst>
+                  <a:ext uri="{0D108BD9-81ED-4DB2-BD59-A6C34878D82A}">
+                    <a16:rowId xmlns:a16="http://schemas.microsoft.com/office/drawing/2014/main" val="10005"/>
+                  </a:ext>
+                </a:extLst>
               </a:tr>
             </a:tbl>
           </a:graphicData>
@@ -5585,7 +5695,7 @@
 </file>
 
 <file path=ppt/slides/slide12.xml><?xml version="1.0" encoding="utf-8"?>
-<p:sld xmlns:a="http://schemas.openxmlformats.org/drawingml/2006/main" xmlns:p="http://schemas.openxmlformats.org/presentationml/2006/main" xmlns:r="http://schemas.openxmlformats.org/officeDocument/2006/relationships">
+<p:sld xmlns:a="http://schemas.openxmlformats.org/drawingml/2006/main" xmlns:r="http://schemas.openxmlformats.org/officeDocument/2006/relationships" xmlns:p="http://schemas.openxmlformats.org/presentationml/2006/main">
   <p:cSld>
     <p:spTree>
       <p:nvGrpSpPr>
@@ -5593,7 +5703,14 @@
         <p:cNvGrpSpPr/>
         <p:nvPr/>
       </p:nvGrpSpPr>
-      <p:grpSpPr/>
+      <p:grpSpPr>
+        <a:xfrm>
+          <a:off x="0" y="0"/>
+          <a:ext cx="0" cy="0"/>
+          <a:chOff x="0" y="0"/>
+          <a:chExt cx="0" cy="0"/>
+        </a:xfrm>
+      </p:grpSpPr>
       <p:sp>
         <p:nvSpPr>
           <p:cNvPr id="2" name="Rectangle 1"/>
@@ -5635,6 +5752,7 @@
           <a:lstStyle/>
           <a:p>
             <a:pPr algn="ctr"/>
+            <a:endParaRPr/>
           </a:p>
         </p:txBody>
       </p:sp>
@@ -5679,6 +5797,7 @@
           <a:lstStyle/>
           <a:p>
             <a:pPr algn="ctr"/>
+            <a:endParaRPr/>
           </a:p>
         </p:txBody>
       </p:sp>
@@ -5699,7 +5818,7 @@
           <a:noFill/>
         </p:spPr>
         <p:txBody>
-          <a:bodyPr wrap="square" anchor="ctr" lIns="50800" rIns="50800" tIns="25400" bIns="25400">
+          <a:bodyPr wrap="square" lIns="50800" tIns="25400" rIns="50800" bIns="25400" anchor="ctr">
             <a:spAutoFit/>
           </a:bodyPr>
           <a:lstStyle/>
@@ -5734,7 +5853,7 @@
           <a:noFill/>
         </p:spPr>
         <p:txBody>
-          <a:bodyPr wrap="square" anchor="ctr" lIns="50800" rIns="50800" tIns="25400" bIns="25400">
+          <a:bodyPr wrap="square" lIns="50800" tIns="25400" rIns="50800" bIns="25400" anchor="ctr">
             <a:spAutoFit/>
           </a:bodyPr>
           <a:lstStyle/>
@@ -5769,7 +5888,7 @@
           <a:noFill/>
         </p:spPr>
         <p:txBody>
-          <a:bodyPr wrap="square" anchor="t" lIns="50800" rIns="50800" tIns="25400" bIns="25400">
+          <a:bodyPr wrap="square" lIns="50800" tIns="25400" rIns="50800" bIns="25400" anchor="t">
             <a:spAutoFit/>
           </a:bodyPr>
           <a:lstStyle/>
@@ -5828,6 +5947,7 @@
           <a:lstStyle/>
           <a:p>
             <a:pPr algn="ctr"/>
+            <a:endParaRPr/>
           </a:p>
         </p:txBody>
       </p:sp>
@@ -5840,28 +5960,28 @@
         <p:spPr>
           <a:xfrm>
             <a:off x="777240" y="1554480"/>
-            <a:ext cx="10789920" cy="640080"/>
-          </a:xfrm>
-          <a:prstGeom prst="rect">
-            <a:avLst/>
-          </a:prstGeom>
-          <a:noFill/>
-        </p:spPr>
-        <p:txBody>
-          <a:bodyPr wrap="square" anchor="t" lIns="50800" rIns="50800" tIns="25400" bIns="25400">
-            <a:spAutoFit/>
-          </a:bodyPr>
-          <a:lstStyle/>
-          <a:p>
-            <a:pPr algn="l"/>
-            <a:r>
-              <a:rPr sz="1400" b="0" i="0">
+            <a:ext cx="10789920" cy="266740"/>
+          </a:xfrm>
+          <a:prstGeom prst="rect">
+            <a:avLst/>
+          </a:prstGeom>
+          <a:noFill/>
+        </p:spPr>
+        <p:txBody>
+          <a:bodyPr wrap="square" lIns="50800" tIns="25400" rIns="50800" bIns="25400" anchor="t">
+            <a:spAutoFit/>
+          </a:bodyPr>
+          <a:lstStyle/>
+          <a:p>
+            <a:pPr algn="l"/>
+            <a:r>
+              <a:rPr sz="1400" b="0" i="0" dirty="0">
                 <a:solidFill>
                   <a:srgbClr val="2D2D2D"/>
                 </a:solidFill>
                 <a:latin typeface="Segoe UI"/>
               </a:rPr>
-              <a:t>Execute CO6 this week (effective Jun 30 retroactively) — $2.7M, 9 workstreams through Oct 30; releases $533,775 holdback.</a:t>
+              <a:t>Execute CO6 this week (effective Jun 30 retroactively)</a:t>
             </a:r>
           </a:p>
         </p:txBody>
@@ -5907,6 +6027,7 @@
           <a:lstStyle/>
           <a:p>
             <a:pPr algn="ctr"/>
+            <a:endParaRPr/>
           </a:p>
         </p:txBody>
       </p:sp>
@@ -5927,7 +6048,7 @@
           <a:noFill/>
         </p:spPr>
         <p:txBody>
-          <a:bodyPr wrap="square" anchor="t" lIns="50800" rIns="50800" tIns="25400" bIns="25400">
+          <a:bodyPr wrap="square" lIns="50800" tIns="25400" rIns="50800" bIns="25400" anchor="t">
             <a:spAutoFit/>
           </a:bodyPr>
           <a:lstStyle/>
@@ -5986,6 +6107,7 @@
           <a:lstStyle/>
           <a:p>
             <a:pPr algn="ctr"/>
+            <a:endParaRPr/>
           </a:p>
         </p:txBody>
       </p:sp>
@@ -6006,7 +6128,7 @@
           <a:noFill/>
         </p:spPr>
         <p:txBody>
-          <a:bodyPr wrap="square" anchor="t" lIns="50800" rIns="50800" tIns="25400" bIns="25400">
+          <a:bodyPr wrap="square" lIns="50800" tIns="25400" rIns="50800" bIns="25400" anchor="t">
             <a:spAutoFit/>
           </a:bodyPr>
           <a:lstStyle/>
@@ -6065,6 +6187,7 @@
           <a:lstStyle/>
           <a:p>
             <a:pPr algn="ctr"/>
+            <a:endParaRPr/>
           </a:p>
         </p:txBody>
       </p:sp>
@@ -6085,7 +6208,7 @@
           <a:noFill/>
         </p:spPr>
         <p:txBody>
-          <a:bodyPr wrap="square" anchor="t" lIns="50800" rIns="50800" tIns="25400" bIns="25400">
+          <a:bodyPr wrap="square" lIns="50800" tIns="25400" rIns="50800" bIns="25400" anchor="t">
             <a:spAutoFit/>
           </a:bodyPr>
           <a:lstStyle/>
@@ -6144,6 +6267,7 @@
           <a:lstStyle/>
           <a:p>
             <a:pPr algn="ctr"/>
+            <a:endParaRPr/>
           </a:p>
         </p:txBody>
       </p:sp>
@@ -6164,7 +6288,7 @@
           <a:noFill/>
         </p:spPr>
         <p:txBody>
-          <a:bodyPr wrap="square" anchor="t" lIns="50800" rIns="50800" tIns="25400" bIns="25400">
+          <a:bodyPr wrap="square" lIns="50800" tIns="25400" rIns="50800" bIns="25400" anchor="t">
             <a:spAutoFit/>
           </a:bodyPr>
           <a:lstStyle/>
@@ -6223,6 +6347,7 @@
           <a:lstStyle/>
           <a:p>
             <a:pPr algn="ctr"/>
+            <a:endParaRPr/>
           </a:p>
         </p:txBody>
       </p:sp>
@@ -6243,7 +6368,7 @@
           <a:noFill/>
         </p:spPr>
         <p:txBody>
-          <a:bodyPr wrap="square" anchor="t" lIns="50800" rIns="50800" tIns="25400" bIns="25400">
+          <a:bodyPr wrap="square" lIns="50800" tIns="25400" rIns="50800" bIns="25400" anchor="t">
             <a:spAutoFit/>
           </a:bodyPr>
           <a:lstStyle/>
@@ -6270,7 +6395,7 @@
 </file>
 
 <file path=ppt/slides/slide13.xml><?xml version="1.0" encoding="utf-8"?>
-<p:sld xmlns:a="http://schemas.openxmlformats.org/drawingml/2006/main" xmlns:p="http://schemas.openxmlformats.org/presentationml/2006/main" xmlns:r="http://schemas.openxmlformats.org/officeDocument/2006/relationships">
+<p:sld xmlns:a="http://schemas.openxmlformats.org/drawingml/2006/main" xmlns:r="http://schemas.openxmlformats.org/officeDocument/2006/relationships" xmlns:p="http://schemas.openxmlformats.org/presentationml/2006/main">
   <p:cSld>
     <p:spTree>
       <p:nvGrpSpPr>
@@ -6278,7 +6403,14 @@
         <p:cNvGrpSpPr/>
         <p:nvPr/>
       </p:nvGrpSpPr>
-      <p:grpSpPr/>
+      <p:grpSpPr>
+        <a:xfrm>
+          <a:off x="0" y="0"/>
+          <a:ext cx="0" cy="0"/>
+          <a:chOff x="0" y="0"/>
+          <a:chExt cx="0" cy="0"/>
+        </a:xfrm>
+      </p:grpSpPr>
       <p:sp>
         <p:nvSpPr>
           <p:cNvPr id="2" name="Rectangle 1"/>
@@ -6320,6 +6452,7 @@
           <a:lstStyle/>
           <a:p>
             <a:pPr algn="ctr"/>
+            <a:endParaRPr/>
           </a:p>
         </p:txBody>
       </p:sp>
@@ -6364,6 +6497,7 @@
           <a:lstStyle/>
           <a:p>
             <a:pPr algn="ctr"/>
+            <a:endParaRPr/>
           </a:p>
         </p:txBody>
       </p:sp>
@@ -6384,7 +6518,7 @@
           <a:noFill/>
         </p:spPr>
         <p:txBody>
-          <a:bodyPr wrap="square" anchor="ctr" lIns="50800" rIns="50800" tIns="25400" bIns="25400">
+          <a:bodyPr wrap="square" lIns="50800" tIns="25400" rIns="50800" bIns="25400" anchor="ctr">
             <a:spAutoFit/>
           </a:bodyPr>
           <a:lstStyle/>
@@ -6419,7 +6553,7 @@
           <a:noFill/>
         </p:spPr>
         <p:txBody>
-          <a:bodyPr wrap="square" anchor="ctr" lIns="50800" rIns="50800" tIns="25400" bIns="25400">
+          <a:bodyPr wrap="square" lIns="50800" tIns="25400" rIns="50800" bIns="25400" anchor="ctr">
             <a:spAutoFit/>
           </a:bodyPr>
           <a:lstStyle/>
@@ -6454,7 +6588,7 @@
           <a:noFill/>
         </p:spPr>
         <p:txBody>
-          <a:bodyPr wrap="square" anchor="t" lIns="50800" rIns="50800" tIns="25400" bIns="25400">
+          <a:bodyPr wrap="square" lIns="50800" tIns="25400" rIns="50800" bIns="25400" anchor="t">
             <a:spAutoFit/>
           </a:bodyPr>
           <a:lstStyle/>
@@ -6489,7 +6623,7 @@
           <a:noFill/>
         </p:spPr>
         <p:txBody>
-          <a:bodyPr wrap="square" anchor="t" lIns="50800" rIns="50800" tIns="25400" bIns="25400">
+          <a:bodyPr wrap="square" lIns="50800" tIns="25400" rIns="50800" bIns="25400" anchor="t">
             <a:spAutoFit/>
           </a:bodyPr>
           <a:lstStyle/>
@@ -6507,15 +6641,12 @@
           </a:p>
           <a:p>
             <a:pPr algn="l"/>
-            <a:r>
-              <a:rPr sz="800" b="0" i="0">
-                <a:solidFill>
-                  <a:srgbClr val="2D2D2D"/>
-                </a:solidFill>
-                <a:latin typeface="Segoe UI"/>
-              </a:rPr>
-              <a:t/>
-            </a:r>
+            <a:endParaRPr sz="1400" b="1" i="0">
+              <a:solidFill>
+                <a:srgbClr val="2D2D2D"/>
+              </a:solidFill>
+              <a:latin typeface="Segoe UI"/>
+            </a:endParaRPr>
           </a:p>
           <a:p>
             <a:pPr algn="l"/>
@@ -6567,15 +6698,12 @@
           </a:p>
           <a:p>
             <a:pPr algn="l"/>
-            <a:r>
-              <a:rPr sz="800" b="0" i="0">
-                <a:solidFill>
-                  <a:srgbClr val="2D2D2D"/>
-                </a:solidFill>
-                <a:latin typeface="Segoe UI"/>
-              </a:rPr>
-              <a:t/>
-            </a:r>
+            <a:endParaRPr sz="1200" b="0" i="0">
+              <a:solidFill>
+                <a:srgbClr val="2E6DB4"/>
+              </a:solidFill>
+              <a:latin typeface="Segoe UI"/>
+            </a:endParaRPr>
           </a:p>
           <a:p>
             <a:pPr algn="l"/>
@@ -6600,7 +6728,7 @@
 </file>
 
 <file path=ppt/slides/slide2.xml><?xml version="1.0" encoding="utf-8"?>
-<p:sld xmlns:a="http://schemas.openxmlformats.org/drawingml/2006/main" xmlns:p="http://schemas.openxmlformats.org/presentationml/2006/main" xmlns:r="http://schemas.openxmlformats.org/officeDocument/2006/relationships">
+<p:sld xmlns:a="http://schemas.openxmlformats.org/drawingml/2006/main" xmlns:r="http://schemas.openxmlformats.org/officeDocument/2006/relationships" xmlns:p="http://schemas.openxmlformats.org/presentationml/2006/main">
   <p:cSld>
     <p:spTree>
       <p:nvGrpSpPr>
@@ -6608,7 +6736,14 @@
         <p:cNvGrpSpPr/>
         <p:nvPr/>
       </p:nvGrpSpPr>
-      <p:grpSpPr/>
+      <p:grpSpPr>
+        <a:xfrm>
+          <a:off x="0" y="0"/>
+          <a:ext cx="0" cy="0"/>
+          <a:chOff x="0" y="0"/>
+          <a:chExt cx="0" cy="0"/>
+        </a:xfrm>
+      </p:grpSpPr>
       <p:sp>
         <p:nvSpPr>
           <p:cNvPr id="2" name="Rectangle 1"/>
@@ -6650,6 +6785,7 @@
           <a:lstStyle/>
           <a:p>
             <a:pPr algn="ctr"/>
+            <a:endParaRPr/>
           </a:p>
         </p:txBody>
       </p:sp>
@@ -6694,6 +6830,7 @@
           <a:lstStyle/>
           <a:p>
             <a:pPr algn="ctr"/>
+            <a:endParaRPr/>
           </a:p>
         </p:txBody>
       </p:sp>
@@ -6714,7 +6851,7 @@
           <a:noFill/>
         </p:spPr>
         <p:txBody>
-          <a:bodyPr wrap="square" anchor="ctr" lIns="50800" rIns="50800" tIns="25400" bIns="25400">
+          <a:bodyPr wrap="square" lIns="50800" tIns="25400" rIns="50800" bIns="25400" anchor="ctr">
             <a:spAutoFit/>
           </a:bodyPr>
           <a:lstStyle/>
@@ -6749,7 +6886,7 @@
           <a:noFill/>
         </p:spPr>
         <p:txBody>
-          <a:bodyPr wrap="square" anchor="ctr" lIns="50800" rIns="50800" tIns="25400" bIns="25400">
+          <a:bodyPr wrap="square" lIns="50800" tIns="25400" rIns="50800" bIns="25400" anchor="ctr">
             <a:spAutoFit/>
           </a:bodyPr>
           <a:lstStyle/>
@@ -6784,7 +6921,7 @@
           <a:noFill/>
         </p:spPr>
         <p:txBody>
-          <a:bodyPr wrap="square" anchor="t" lIns="50800" rIns="50800" tIns="25400" bIns="25400">
+          <a:bodyPr wrap="square" lIns="50800" tIns="25400" rIns="50800" bIns="25400" anchor="t">
             <a:spAutoFit/>
           </a:bodyPr>
           <a:lstStyle/>
@@ -6819,7 +6956,7 @@
           <a:noFill/>
         </p:spPr>
         <p:txBody>
-          <a:bodyPr wrap="square" anchor="t" lIns="50800" rIns="50800" tIns="25400" bIns="25400">
+          <a:bodyPr wrap="square" lIns="50800" tIns="25400" rIns="50800" bIns="25400" anchor="t">
             <a:spAutoFit/>
           </a:bodyPr>
           <a:lstStyle/>
@@ -6878,6 +7015,7 @@
           <a:lstStyle/>
           <a:p>
             <a:pPr algn="ctr"/>
+            <a:endParaRPr/>
           </a:p>
         </p:txBody>
       </p:sp>
@@ -6898,7 +7036,7 @@
           <a:noFill/>
         </p:spPr>
         <p:txBody>
-          <a:bodyPr wrap="square" anchor="t" lIns="50800" rIns="50800" tIns="25400" bIns="25400">
+          <a:bodyPr wrap="square" lIns="50800" tIns="25400" rIns="50800" bIns="25400" anchor="t">
             <a:spAutoFit/>
           </a:bodyPr>
           <a:lstStyle/>
@@ -6969,6 +7107,7 @@
           <a:lstStyle/>
           <a:p>
             <a:pPr algn="ctr"/>
+            <a:endParaRPr/>
           </a:p>
         </p:txBody>
       </p:sp>
@@ -6989,7 +7128,7 @@
           <a:noFill/>
         </p:spPr>
         <p:txBody>
-          <a:bodyPr wrap="square" anchor="t" lIns="50800" rIns="50800" tIns="25400" bIns="25400">
+          <a:bodyPr wrap="square" lIns="50800" tIns="25400" rIns="50800" bIns="25400" anchor="t">
             <a:spAutoFit/>
           </a:bodyPr>
           <a:lstStyle/>
@@ -7060,6 +7199,7 @@
           <a:lstStyle/>
           <a:p>
             <a:pPr algn="ctr"/>
+            <a:endParaRPr/>
           </a:p>
         </p:txBody>
       </p:sp>
@@ -7080,7 +7220,7 @@
           <a:noFill/>
         </p:spPr>
         <p:txBody>
-          <a:bodyPr wrap="square" anchor="t" lIns="50800" rIns="50800" tIns="25400" bIns="25400">
+          <a:bodyPr wrap="square" lIns="50800" tIns="25400" rIns="50800" bIns="25400" anchor="t">
             <a:spAutoFit/>
           </a:bodyPr>
           <a:lstStyle/>
@@ -7127,7 +7267,7 @@
           <a:noFill/>
         </p:spPr>
         <p:txBody>
-          <a:bodyPr wrap="square" anchor="t" lIns="50800" rIns="50800" tIns="25400" bIns="25400">
+          <a:bodyPr wrap="square" lIns="50800" tIns="25400" rIns="50800" bIns="25400" anchor="t">
             <a:spAutoFit/>
           </a:bodyPr>
           <a:lstStyle/>
@@ -7182,7 +7322,7 @@
           </a:fontRef>
         </p:style>
         <p:txBody>
-          <a:bodyPr rtlCol="0" anchor="ctr" wrap="none"/>
+          <a:bodyPr wrap="none" rtlCol="0" anchor="ctr"/>
           <a:lstStyle/>
           <a:p>
             <a:pPr algn="ctr"/>
@@ -7215,7 +7355,7 @@
           <a:noFill/>
         </p:spPr>
         <p:txBody>
-          <a:bodyPr wrap="square" anchor="t" lIns="50800" rIns="50800" tIns="25400" bIns="25400">
+          <a:bodyPr wrap="square" lIns="50800" tIns="25400" rIns="50800" bIns="25400" anchor="t">
             <a:spAutoFit/>
           </a:bodyPr>
           <a:lstStyle/>
@@ -7270,7 +7410,7 @@
           </a:fontRef>
         </p:style>
         <p:txBody>
-          <a:bodyPr rtlCol="0" anchor="ctr" wrap="none"/>
+          <a:bodyPr wrap="none" rtlCol="0" anchor="ctr"/>
           <a:lstStyle/>
           <a:p>
             <a:pPr algn="ctr"/>
@@ -7303,7 +7443,7 @@
           <a:noFill/>
         </p:spPr>
         <p:txBody>
-          <a:bodyPr wrap="square" anchor="t" lIns="50800" rIns="50800" tIns="25400" bIns="25400">
+          <a:bodyPr wrap="square" lIns="50800" tIns="25400" rIns="50800" bIns="25400" anchor="t">
             <a:spAutoFit/>
           </a:bodyPr>
           <a:lstStyle/>
@@ -7358,7 +7498,7 @@
           </a:fontRef>
         </p:style>
         <p:txBody>
-          <a:bodyPr rtlCol="0" anchor="ctr" wrap="none"/>
+          <a:bodyPr wrap="none" rtlCol="0" anchor="ctr"/>
           <a:lstStyle/>
           <a:p>
             <a:pPr algn="ctr"/>
@@ -7391,7 +7531,7 @@
           <a:noFill/>
         </p:spPr>
         <p:txBody>
-          <a:bodyPr wrap="square" anchor="t" lIns="50800" rIns="50800" tIns="25400" bIns="25400">
+          <a:bodyPr wrap="square" lIns="50800" tIns="25400" rIns="50800" bIns="25400" anchor="t">
             <a:spAutoFit/>
           </a:bodyPr>
           <a:lstStyle/>
@@ -7418,7 +7558,7 @@
 </file>
 
 <file path=ppt/slides/slide3.xml><?xml version="1.0" encoding="utf-8"?>
-<p:sld xmlns:a="http://schemas.openxmlformats.org/drawingml/2006/main" xmlns:p="http://schemas.openxmlformats.org/presentationml/2006/main" xmlns:r="http://schemas.openxmlformats.org/officeDocument/2006/relationships">
+<p:sld xmlns:a="http://schemas.openxmlformats.org/drawingml/2006/main" xmlns:r="http://schemas.openxmlformats.org/officeDocument/2006/relationships" xmlns:p="http://schemas.openxmlformats.org/presentationml/2006/main">
   <p:cSld>
     <p:spTree>
       <p:nvGrpSpPr>
@@ -7426,7 +7566,14 @@
         <p:cNvGrpSpPr/>
         <p:nvPr/>
       </p:nvGrpSpPr>
-      <p:grpSpPr/>
+      <p:grpSpPr>
+        <a:xfrm>
+          <a:off x="0" y="0"/>
+          <a:ext cx="0" cy="0"/>
+          <a:chOff x="0" y="0"/>
+          <a:chExt cx="0" cy="0"/>
+        </a:xfrm>
+      </p:grpSpPr>
       <p:sp>
         <p:nvSpPr>
           <p:cNvPr id="2" name="Rectangle 1"/>
@@ -7468,6 +7615,7 @@
           <a:lstStyle/>
           <a:p>
             <a:pPr algn="ctr"/>
+            <a:endParaRPr/>
           </a:p>
         </p:txBody>
       </p:sp>
@@ -7512,6 +7660,7 @@
           <a:lstStyle/>
           <a:p>
             <a:pPr algn="ctr"/>
+            <a:endParaRPr/>
           </a:p>
         </p:txBody>
       </p:sp>
@@ -7532,7 +7681,7 @@
           <a:noFill/>
         </p:spPr>
         <p:txBody>
-          <a:bodyPr wrap="square" anchor="ctr" lIns="50800" rIns="50800" tIns="25400" bIns="25400">
+          <a:bodyPr wrap="square" lIns="50800" tIns="25400" rIns="50800" bIns="25400" anchor="ctr">
             <a:spAutoFit/>
           </a:bodyPr>
           <a:lstStyle/>
@@ -7567,7 +7716,7 @@
           <a:noFill/>
         </p:spPr>
         <p:txBody>
-          <a:bodyPr wrap="square" anchor="ctr" lIns="50800" rIns="50800" tIns="25400" bIns="25400">
+          <a:bodyPr wrap="square" lIns="50800" tIns="25400" rIns="50800" bIns="25400" anchor="ctr">
             <a:spAutoFit/>
           </a:bodyPr>
           <a:lstStyle/>
@@ -7602,7 +7751,7 @@
           <a:noFill/>
         </p:spPr>
         <p:txBody>
-          <a:bodyPr wrap="square" anchor="t" lIns="50800" rIns="50800" tIns="25400" bIns="25400">
+          <a:bodyPr wrap="square" lIns="50800" tIns="25400" rIns="50800" bIns="25400" anchor="t">
             <a:spAutoFit/>
           </a:bodyPr>
           <a:lstStyle/>
@@ -7657,7 +7806,7 @@
           </a:fontRef>
         </p:style>
         <p:txBody>
-          <a:bodyPr rtlCol="0" anchor="ctr" wrap="none"/>
+          <a:bodyPr wrap="none" rtlCol="0" anchor="ctr"/>
           <a:lstStyle/>
           <a:p>
             <a:pPr algn="ctr"/>
@@ -7682,28 +7831,46 @@
         <p:spPr>
           <a:xfrm>
             <a:off x="502920" y="1691640"/>
-            <a:ext cx="11155680" cy="822960"/>
-          </a:xfrm>
-          <a:prstGeom prst="rect">
-            <a:avLst/>
-          </a:prstGeom>
-          <a:noFill/>
-        </p:spPr>
-        <p:txBody>
-          <a:bodyPr wrap="square" anchor="t" lIns="50800" rIns="50800" tIns="25400" bIns="25400">
-            <a:spAutoFit/>
-          </a:bodyPr>
-          <a:lstStyle/>
-          <a:p>
-            <a:pPr algn="l"/>
-            <a:r>
-              <a:rPr sz="1250" b="0" i="0">
+            <a:ext cx="11155680" cy="436017"/>
+          </a:xfrm>
+          <a:prstGeom prst="rect">
+            <a:avLst/>
+          </a:prstGeom>
+          <a:noFill/>
+        </p:spPr>
+        <p:txBody>
+          <a:bodyPr wrap="square" lIns="50800" tIns="25400" rIns="50800" bIns="25400" anchor="t">
+            <a:spAutoFit/>
+          </a:bodyPr>
+          <a:lstStyle/>
+          <a:p>
+            <a:pPr algn="l"/>
+            <a:r>
+              <a:rPr sz="1250" b="0" i="0" dirty="0">
                 <a:solidFill>
                   <a:srgbClr val="2D2D2D"/>
                 </a:solidFill>
                 <a:latin typeface="Segoe UI"/>
               </a:rPr>
-              <a:t>Sprint 2.4 closed Jul 7 with 9 items / 10 pts accepted. Delivery momentum is real - SOX BA review done, Airlift exports complete, CI retirement executed - but the CO5 acceptance gate (Data Dictionary CCB approval Jul 21) is 13 days out and CO6 is still unsigned. Dev code freeze (Jul 4-18) is now active, constraining Sprint 2.5 delivery capacity. The $533,775 holdback stands until CO6 is executed or CO5 is formally accepted.</a:t>
+              <a:t>Delivery momentum is real - SOX BA review done, Airlift exports complete, CI retirement executed - but the CO5 acceptance gate (Data Dictionary CCB approval Jul 21) is 13 days out</a:t>
+            </a:r>
+            <a:r>
+              <a:rPr lang="en-US" sz="1250" b="0" i="0" dirty="0">
+                <a:solidFill>
+                  <a:srgbClr val="2D2D2D"/>
+                </a:solidFill>
+                <a:latin typeface="Segoe UI"/>
+              </a:rPr>
+              <a:t>.</a:t>
+            </a:r>
+            <a:r>
+              <a:rPr sz="1250" b="0" i="0" dirty="0">
+                <a:solidFill>
+                  <a:srgbClr val="2D2D2D"/>
+                </a:solidFill>
+                <a:latin typeface="Segoe UI"/>
+              </a:rPr>
+              <a:t> Dev code freeze (Jul 4-18) is now active, constraining Sprint 2.5 delivery capacity.</a:t>
             </a:r>
           </a:p>
         </p:txBody>
@@ -7725,7 +7892,7 @@
           <a:noFill/>
         </p:spPr>
         <p:txBody>
-          <a:bodyPr wrap="square" anchor="t" lIns="50800" rIns="50800" tIns="25400" bIns="25400">
+          <a:bodyPr wrap="square" lIns="50800" tIns="25400" rIns="50800" bIns="25400" anchor="t">
             <a:spAutoFit/>
           </a:bodyPr>
           <a:lstStyle/>
@@ -7752,28 +7919,82 @@
         <p:spPr>
           <a:xfrm>
             <a:off x="640080" y="3017520"/>
-            <a:ext cx="5486400" cy="640080"/>
-          </a:xfrm>
-          <a:prstGeom prst="rect">
-            <a:avLst/>
-          </a:prstGeom>
-          <a:noFill/>
-        </p:spPr>
-        <p:txBody>
-          <a:bodyPr wrap="square" anchor="t" lIns="50800" rIns="50800" tIns="25400" bIns="25400">
-            <a:spAutoFit/>
-          </a:bodyPr>
-          <a:lstStyle/>
-          <a:p>
-            <a:pPr algn="l"/>
-            <a:r>
-              <a:rPr sz="1100" b="0" i="0">
+            <a:ext cx="5486400" cy="389850"/>
+          </a:xfrm>
+          <a:prstGeom prst="rect">
+            <a:avLst/>
+          </a:prstGeom>
+          <a:noFill/>
+        </p:spPr>
+        <p:txBody>
+          <a:bodyPr wrap="square" lIns="50800" tIns="25400" rIns="50800" bIns="25400" anchor="t">
+            <a:spAutoFit/>
+          </a:bodyPr>
+          <a:lstStyle/>
+          <a:p>
+            <a:pPr algn="l"/>
+            <a:r>
+              <a:rPr sz="1100" b="0" i="0" dirty="0">
                 <a:solidFill>
                   <a:srgbClr val="2D2D2D"/>
                 </a:solidFill>
                 <a:latin typeface="Segoe UI"/>
               </a:rPr>
-              <a:t>+  Sprint 2.4 closed (Jul 7) - 9 items / 10 pts accepted: SOX BA review, Airlift exports (PA/KY VMware + PA Physical), bulk CI retirement, NowAssist Duplicate CIs skill, IRE behaviour review spike.</a:t>
+              <a:t>+  Sprint 2.4 closed (Jul 7)</a:t>
+            </a:r>
+            <a:r>
+              <a:rPr lang="en-US" sz="1100" b="0" i="0" dirty="0">
+                <a:solidFill>
+                  <a:srgbClr val="2D2D2D"/>
+                </a:solidFill>
+                <a:latin typeface="Segoe UI"/>
+              </a:rPr>
+              <a:t>;</a:t>
+            </a:r>
+            <a:r>
+              <a:rPr sz="1100" b="0" i="0" dirty="0">
+                <a:solidFill>
+                  <a:srgbClr val="2D2D2D"/>
+                </a:solidFill>
+                <a:latin typeface="Segoe UI"/>
+              </a:rPr>
+              <a:t> SOX BA review, Airlift exports (PA/KY VMware + PA Physical), bulk CI retirement, </a:t>
+            </a:r>
+            <a:r>
+              <a:rPr sz="1100" b="0" i="0" dirty="0" err="1">
+                <a:solidFill>
+                  <a:srgbClr val="2D2D2D"/>
+                </a:solidFill>
+                <a:latin typeface="Segoe UI"/>
+              </a:rPr>
+              <a:t>NowAssist</a:t>
+            </a:r>
+            <a:r>
+              <a:rPr sz="1100" b="0" i="0" dirty="0">
+                <a:solidFill>
+                  <a:srgbClr val="2D2D2D"/>
+                </a:solidFill>
+                <a:latin typeface="Segoe UI"/>
+              </a:rPr>
+              <a:t> Duplicate CIs skill, IRE </a:t>
+            </a:r>
+            <a:r>
+              <a:rPr sz="1100" b="0" i="0" dirty="0" err="1">
+                <a:solidFill>
+                  <a:srgbClr val="2D2D2D"/>
+                </a:solidFill>
+                <a:latin typeface="Segoe UI"/>
+              </a:rPr>
+              <a:t>behaviour</a:t>
+            </a:r>
+            <a:r>
+              <a:rPr sz="1100" b="0" i="0" dirty="0">
+                <a:solidFill>
+                  <a:srgbClr val="2D2D2D"/>
+                </a:solidFill>
+                <a:latin typeface="Segoe UI"/>
+              </a:rPr>
+              <a:t> review spike.</a:t>
             </a:r>
           </a:p>
         </p:txBody>
@@ -7795,7 +8016,7 @@
           <a:noFill/>
         </p:spPr>
         <p:txBody>
-          <a:bodyPr wrap="square" anchor="t" lIns="50800" rIns="50800" tIns="25400" bIns="25400">
+          <a:bodyPr wrap="square" lIns="50800" tIns="25400" rIns="50800" bIns="25400" anchor="t">
             <a:spAutoFit/>
           </a:bodyPr>
           <a:lstStyle/>
@@ -7830,7 +8051,7 @@
           <a:noFill/>
         </p:spPr>
         <p:txBody>
-          <a:bodyPr wrap="square" anchor="t" lIns="50800" rIns="50800" tIns="25400" bIns="25400">
+          <a:bodyPr wrap="square" lIns="50800" tIns="25400" rIns="50800" bIns="25400" anchor="t">
             <a:spAutoFit/>
           </a:bodyPr>
           <a:lstStyle/>
@@ -7844,41 +8065,6 @@
                 <a:latin typeface="Segoe UI"/>
               </a:rPr>
               <a:t>+  Data Dictionaries (Servers/Computers/Biz Apps/DB) delivered to Validation - CCB review Jul 7-20, approval target Jul 21.</a:t>
-            </a:r>
-          </a:p>
-        </p:txBody>
-      </p:sp>
-      <p:sp>
-        <p:nvSpPr>
-          <p:cNvPr id="13" name="TextBox 12"/>
-          <p:cNvSpPr txBox="1"/>
-          <p:nvPr/>
-        </p:nvSpPr>
-        <p:spPr>
-          <a:xfrm>
-            <a:off x="640080" y="5266944"/>
-            <a:ext cx="5486400" cy="640080"/>
-          </a:xfrm>
-          <a:prstGeom prst="rect">
-            <a:avLst/>
-          </a:prstGeom>
-          <a:noFill/>
-        </p:spPr>
-        <p:txBody>
-          <a:bodyPr wrap="square" anchor="t" lIns="50800" rIns="50800" tIns="25400" bIns="25400">
-            <a:spAutoFit/>
-          </a:bodyPr>
-          <a:lstStyle/>
-          <a:p>
-            <a:pPr algn="l"/>
-            <a:r>
-              <a:rPr sz="1100" b="0" i="0">
-                <a:solidFill>
-                  <a:srgbClr val="2D2D2D"/>
-                </a:solidFill>
-                <a:latin typeface="Segoe UI"/>
-              </a:rPr>
-              <a:t>+  12 items / 18 pts in validation entering Sprint 2.5 - largest carry-over pipeline of PI-2.</a:t>
             </a:r>
           </a:p>
         </p:txBody>
@@ -7900,7 +8086,7 @@
           <a:noFill/>
         </p:spPr>
         <p:txBody>
-          <a:bodyPr wrap="square" anchor="t" lIns="50800" rIns="50800" tIns="25400" bIns="25400">
+          <a:bodyPr wrap="square" lIns="50800" tIns="25400" rIns="50800" bIns="25400" anchor="t">
             <a:spAutoFit/>
           </a:bodyPr>
           <a:lstStyle/>
@@ -7935,7 +8121,7 @@
           <a:noFill/>
         </p:spPr>
         <p:txBody>
-          <a:bodyPr wrap="square" anchor="t" lIns="50800" rIns="50800" tIns="25400" bIns="25400">
+          <a:bodyPr wrap="square" lIns="50800" tIns="25400" rIns="50800" bIns="25400" anchor="t">
             <a:spAutoFit/>
           </a:bodyPr>
           <a:lstStyle/>
@@ -7970,7 +8156,7 @@
           <a:noFill/>
         </p:spPr>
         <p:txBody>
-          <a:bodyPr wrap="square" anchor="t" lIns="50800" rIns="50800" tIns="25400" bIns="25400">
+          <a:bodyPr wrap="square" lIns="50800" tIns="25400" rIns="50800" bIns="25400" anchor="t">
             <a:spAutoFit/>
           </a:bodyPr>
           <a:lstStyle/>
@@ -8005,7 +8191,7 @@
           <a:noFill/>
         </p:spPr>
         <p:txBody>
-          <a:bodyPr wrap="square" anchor="t" lIns="50800" rIns="50800" tIns="25400" bIns="25400">
+          <a:bodyPr wrap="square" lIns="50800" tIns="25400" rIns="50800" bIns="25400" anchor="t">
             <a:spAutoFit/>
           </a:bodyPr>
           <a:lstStyle/>
@@ -8032,7 +8218,7 @@
 </file>
 
 <file path=ppt/slides/slide4.xml><?xml version="1.0" encoding="utf-8"?>
-<p:sld xmlns:a="http://schemas.openxmlformats.org/drawingml/2006/main" xmlns:p="http://schemas.openxmlformats.org/presentationml/2006/main" xmlns:r="http://schemas.openxmlformats.org/officeDocument/2006/relationships">
+<p:sld xmlns:a="http://schemas.openxmlformats.org/drawingml/2006/main" xmlns:r="http://schemas.openxmlformats.org/officeDocument/2006/relationships" xmlns:p="http://schemas.openxmlformats.org/presentationml/2006/main">
   <p:cSld>
     <p:spTree>
       <p:nvGrpSpPr>
@@ -8040,7 +8226,14 @@
         <p:cNvGrpSpPr/>
         <p:nvPr/>
       </p:nvGrpSpPr>
-      <p:grpSpPr/>
+      <p:grpSpPr>
+        <a:xfrm>
+          <a:off x="0" y="0"/>
+          <a:ext cx="0" cy="0"/>
+          <a:chOff x="0" y="0"/>
+          <a:chExt cx="0" cy="0"/>
+        </a:xfrm>
+      </p:grpSpPr>
       <p:sp>
         <p:nvSpPr>
           <p:cNvPr id="2" name="Rectangle 1"/>
@@ -8082,6 +8275,7 @@
           <a:lstStyle/>
           <a:p>
             <a:pPr algn="ctr"/>
+            <a:endParaRPr/>
           </a:p>
         </p:txBody>
       </p:sp>
@@ -8126,6 +8320,7 @@
           <a:lstStyle/>
           <a:p>
             <a:pPr algn="ctr"/>
+            <a:endParaRPr/>
           </a:p>
         </p:txBody>
       </p:sp>
@@ -8146,7 +8341,7 @@
           <a:noFill/>
         </p:spPr>
         <p:txBody>
-          <a:bodyPr wrap="square" anchor="ctr" lIns="50800" rIns="50800" tIns="25400" bIns="25400">
+          <a:bodyPr wrap="square" lIns="50800" tIns="25400" rIns="50800" bIns="25400" anchor="ctr">
             <a:spAutoFit/>
           </a:bodyPr>
           <a:lstStyle/>
@@ -8181,7 +8376,7 @@
           <a:noFill/>
         </p:spPr>
         <p:txBody>
-          <a:bodyPr wrap="square" anchor="ctr" lIns="50800" rIns="50800" tIns="25400" bIns="25400">
+          <a:bodyPr wrap="square" lIns="50800" tIns="25400" rIns="50800" bIns="25400" anchor="ctr">
             <a:spAutoFit/>
           </a:bodyPr>
           <a:lstStyle/>
@@ -8216,7 +8411,7 @@
           <a:noFill/>
         </p:spPr>
         <p:txBody>
-          <a:bodyPr wrap="square" anchor="t" lIns="50800" rIns="50800" tIns="25400" bIns="25400">
+          <a:bodyPr wrap="square" lIns="50800" tIns="25400" rIns="50800" bIns="25400" anchor="t">
             <a:spAutoFit/>
           </a:bodyPr>
           <a:lstStyle/>
@@ -8275,6 +8470,7 @@
           <a:lstStyle/>
           <a:p>
             <a:pPr algn="ctr"/>
+            <a:endParaRPr/>
           </a:p>
         </p:txBody>
       </p:sp>
@@ -8319,6 +8515,7 @@
           <a:lstStyle/>
           <a:p>
             <a:pPr algn="ctr"/>
+            <a:endParaRPr/>
           </a:p>
         </p:txBody>
       </p:sp>
@@ -8339,7 +8536,7 @@
           <a:noFill/>
         </p:spPr>
         <p:txBody>
-          <a:bodyPr wrap="square" anchor="ctr" lIns="50800" rIns="50800" tIns="25400" bIns="25400">
+          <a:bodyPr wrap="square" lIns="50800" tIns="25400" rIns="50800" bIns="25400" anchor="ctr">
             <a:spAutoFit/>
           </a:bodyPr>
           <a:lstStyle/>
@@ -8374,7 +8571,7 @@
           <a:noFill/>
         </p:spPr>
         <p:txBody>
-          <a:bodyPr wrap="square" anchor="t" lIns="50800" rIns="50800" tIns="25400" bIns="25400">
+          <a:bodyPr wrap="square" lIns="50800" tIns="25400" rIns="50800" bIns="25400" anchor="t">
             <a:spAutoFit/>
           </a:bodyPr>
           <a:lstStyle/>
@@ -8409,7 +8606,7 @@
           <a:noFill/>
         </p:spPr>
         <p:txBody>
-          <a:bodyPr wrap="square" anchor="t" lIns="50800" rIns="50800" tIns="25400" bIns="25400">
+          <a:bodyPr wrap="square" lIns="50800" tIns="25400" rIns="50800" bIns="25400" anchor="t">
             <a:spAutoFit/>
           </a:bodyPr>
           <a:lstStyle/>
@@ -8456,7 +8653,7 @@
           <a:noFill/>
         </p:spPr>
         <p:txBody>
-          <a:bodyPr wrap="square" anchor="t" lIns="50800" rIns="50800" tIns="25400" bIns="25400">
+          <a:bodyPr wrap="square" lIns="50800" tIns="25400" rIns="50800" bIns="25400" anchor="t">
             <a:spAutoFit/>
           </a:bodyPr>
           <a:lstStyle/>
@@ -8515,6 +8712,7 @@
           <a:lstStyle/>
           <a:p>
             <a:pPr algn="ctr"/>
+            <a:endParaRPr/>
           </a:p>
         </p:txBody>
       </p:sp>
@@ -8559,6 +8757,7 @@
           <a:lstStyle/>
           <a:p>
             <a:pPr algn="ctr"/>
+            <a:endParaRPr/>
           </a:p>
         </p:txBody>
       </p:sp>
@@ -8579,7 +8778,7 @@
           <a:noFill/>
         </p:spPr>
         <p:txBody>
-          <a:bodyPr wrap="square" anchor="ctr" lIns="50800" rIns="50800" tIns="25400" bIns="25400">
+          <a:bodyPr wrap="square" lIns="50800" tIns="25400" rIns="50800" bIns="25400" anchor="ctr">
             <a:spAutoFit/>
           </a:bodyPr>
           <a:lstStyle/>
@@ -8614,7 +8813,7 @@
           <a:noFill/>
         </p:spPr>
         <p:txBody>
-          <a:bodyPr wrap="square" anchor="t" lIns="50800" rIns="50800" tIns="25400" bIns="25400">
+          <a:bodyPr wrap="square" lIns="50800" tIns="25400" rIns="50800" bIns="25400" anchor="t">
             <a:spAutoFit/>
           </a:bodyPr>
           <a:lstStyle/>
@@ -8649,7 +8848,7 @@
           <a:noFill/>
         </p:spPr>
         <p:txBody>
-          <a:bodyPr wrap="square" anchor="t" lIns="50800" rIns="50800" tIns="25400" bIns="25400">
+          <a:bodyPr wrap="square" lIns="50800" tIns="25400" rIns="50800" bIns="25400" anchor="t">
             <a:spAutoFit/>
           </a:bodyPr>
           <a:lstStyle/>
@@ -8696,7 +8895,7 @@
           <a:noFill/>
         </p:spPr>
         <p:txBody>
-          <a:bodyPr wrap="square" anchor="t" lIns="50800" rIns="50800" tIns="25400" bIns="25400">
+          <a:bodyPr wrap="square" lIns="50800" tIns="25400" rIns="50800" bIns="25400" anchor="t">
             <a:spAutoFit/>
           </a:bodyPr>
           <a:lstStyle/>
@@ -8755,6 +8954,7 @@
           <a:lstStyle/>
           <a:p>
             <a:pPr algn="ctr"/>
+            <a:endParaRPr/>
           </a:p>
         </p:txBody>
       </p:sp>
@@ -8799,6 +8999,7 @@
           <a:lstStyle/>
           <a:p>
             <a:pPr algn="ctr"/>
+            <a:endParaRPr/>
           </a:p>
         </p:txBody>
       </p:sp>
@@ -8819,7 +9020,7 @@
           <a:noFill/>
         </p:spPr>
         <p:txBody>
-          <a:bodyPr wrap="square" anchor="ctr" lIns="50800" rIns="50800" tIns="25400" bIns="25400">
+          <a:bodyPr wrap="square" lIns="50800" tIns="25400" rIns="50800" bIns="25400" anchor="ctr">
             <a:spAutoFit/>
           </a:bodyPr>
           <a:lstStyle/>
@@ -8854,7 +9055,7 @@
           <a:noFill/>
         </p:spPr>
         <p:txBody>
-          <a:bodyPr wrap="square" anchor="t" lIns="50800" rIns="50800" tIns="25400" bIns="25400">
+          <a:bodyPr wrap="square" lIns="50800" tIns="25400" rIns="50800" bIns="25400" anchor="t">
             <a:spAutoFit/>
           </a:bodyPr>
           <a:lstStyle/>
@@ -8889,7 +9090,7 @@
           <a:noFill/>
         </p:spPr>
         <p:txBody>
-          <a:bodyPr wrap="square" anchor="t" lIns="50800" rIns="50800" tIns="25400" bIns="25400">
+          <a:bodyPr wrap="square" lIns="50800" tIns="25400" rIns="50800" bIns="25400" anchor="t">
             <a:spAutoFit/>
           </a:bodyPr>
           <a:lstStyle/>
@@ -8936,7 +9137,7 @@
           <a:noFill/>
         </p:spPr>
         <p:txBody>
-          <a:bodyPr wrap="square" anchor="t" lIns="50800" rIns="50800" tIns="25400" bIns="25400">
+          <a:bodyPr wrap="square" lIns="50800" tIns="25400" rIns="50800" bIns="25400" anchor="t">
             <a:spAutoFit/>
           </a:bodyPr>
           <a:lstStyle/>
@@ -8950,41 +9151,6 @@
                 <a:latin typeface="Segoe UI"/>
               </a:rPr>
               <a:t>Part 1 (1428703) still Active - did not close in 2.4; dev freeze further delays; Part 2 (1428704) status unconfirmed (G4); CO5 bar = evaluate + document; CO6 (Sep 30) delivers full one-way PROD integration (ServiceNow → Qualys)</a:t>
-            </a:r>
-          </a:p>
-        </p:txBody>
-      </p:sp>
-      <p:sp>
-        <p:nvSpPr>
-          <p:cNvPr id="25" name="TextBox 24"/>
-          <p:cNvSpPr txBox="1"/>
-          <p:nvPr/>
-        </p:nvSpPr>
-        <p:spPr>
-          <a:xfrm>
-            <a:off x="502920" y="6144768"/>
-            <a:ext cx="11201400" cy="320040"/>
-          </a:xfrm>
-          <a:prstGeom prst="rect">
-            <a:avLst/>
-          </a:prstGeom>
-          <a:noFill/>
-        </p:spPr>
-        <p:txBody>
-          <a:bodyPr wrap="square" anchor="t" lIns="50800" rIns="50800" tIns="25400" bIns="25400">
-            <a:spAutoFit/>
-          </a:bodyPr>
-          <a:lstStyle/>
-          <a:p>
-            <a:pPr algn="l"/>
-            <a:r>
-              <a:rPr sz="850" b="0" i="1">
-                <a:solidFill>
-                  <a:srgbClr val="6B7280"/>
-                </a:solidFill>
-                <a:latin typeface="Segoe UI"/>
-              </a:rPr>
-              <a:t>Sprint 2.4 final board snapshot (Jul 8). Accepted/Done: 9 items / 10 pts. 12 items / 18 pts in validation carrying into Sprint 2.5. CO6 unsigned as of Jul 8 — $533,775 holdback risk persists.</a:t>
             </a:r>
           </a:p>
         </p:txBody>
@@ -8998,7 +9164,7 @@
 </file>
 
 <file path=ppt/slides/slide5.xml><?xml version="1.0" encoding="utf-8"?>
-<p:sld xmlns:a="http://schemas.openxmlformats.org/drawingml/2006/main" xmlns:p="http://schemas.openxmlformats.org/presentationml/2006/main" xmlns:r="http://schemas.openxmlformats.org/officeDocument/2006/relationships">
+<p:sld xmlns:a="http://schemas.openxmlformats.org/drawingml/2006/main" xmlns:r="http://schemas.openxmlformats.org/officeDocument/2006/relationships" xmlns:p="http://schemas.openxmlformats.org/presentationml/2006/main">
   <p:cSld>
     <p:spTree>
       <p:nvGrpSpPr>
@@ -9006,7 +9172,14 @@
         <p:cNvGrpSpPr/>
         <p:nvPr/>
       </p:nvGrpSpPr>
-      <p:grpSpPr/>
+      <p:grpSpPr>
+        <a:xfrm>
+          <a:off x="0" y="0"/>
+          <a:ext cx="0" cy="0"/>
+          <a:chOff x="0" y="0"/>
+          <a:chExt cx="0" cy="0"/>
+        </a:xfrm>
+      </p:grpSpPr>
       <p:sp>
         <p:nvSpPr>
           <p:cNvPr id="2" name="Rectangle 1"/>
@@ -9048,6 +9221,7 @@
           <a:lstStyle/>
           <a:p>
             <a:pPr algn="ctr"/>
+            <a:endParaRPr/>
           </a:p>
         </p:txBody>
       </p:sp>
@@ -9092,6 +9266,7 @@
           <a:lstStyle/>
           <a:p>
             <a:pPr algn="ctr"/>
+            <a:endParaRPr/>
           </a:p>
         </p:txBody>
       </p:sp>
@@ -9112,7 +9287,7 @@
           <a:noFill/>
         </p:spPr>
         <p:txBody>
-          <a:bodyPr wrap="square" anchor="ctr" lIns="50800" rIns="50800" tIns="25400" bIns="25400">
+          <a:bodyPr wrap="square" lIns="50800" tIns="25400" rIns="50800" bIns="25400" anchor="ctr">
             <a:spAutoFit/>
           </a:bodyPr>
           <a:lstStyle/>
@@ -9147,7 +9322,7 @@
           <a:noFill/>
         </p:spPr>
         <p:txBody>
-          <a:bodyPr wrap="square" anchor="ctr" lIns="50800" rIns="50800" tIns="25400" bIns="25400">
+          <a:bodyPr wrap="square" lIns="50800" tIns="25400" rIns="50800" bIns="25400" anchor="ctr">
             <a:spAutoFit/>
           </a:bodyPr>
           <a:lstStyle/>
@@ -9182,7 +9357,7 @@
           <a:noFill/>
         </p:spPr>
         <p:txBody>
-          <a:bodyPr wrap="square" anchor="t" lIns="50800" rIns="50800" tIns="25400" bIns="25400">
+          <a:bodyPr wrap="square" lIns="50800" tIns="25400" rIns="50800" bIns="25400" anchor="t">
             <a:spAutoFit/>
           </a:bodyPr>
           <a:lstStyle/>
@@ -9241,6 +9416,7 @@
           <a:lstStyle/>
           <a:p>
             <a:pPr algn="ctr"/>
+            <a:endParaRPr/>
           </a:p>
         </p:txBody>
       </p:sp>
@@ -9285,6 +9461,7 @@
           <a:lstStyle/>
           <a:p>
             <a:pPr algn="ctr"/>
+            <a:endParaRPr/>
           </a:p>
         </p:txBody>
       </p:sp>
@@ -9305,7 +9482,7 @@
           <a:noFill/>
         </p:spPr>
         <p:txBody>
-          <a:bodyPr wrap="square" anchor="ctr" lIns="50800" rIns="50800" tIns="25400" bIns="25400">
+          <a:bodyPr wrap="square" lIns="50800" tIns="25400" rIns="50800" bIns="25400" anchor="ctr">
             <a:spAutoFit/>
           </a:bodyPr>
           <a:lstStyle/>
@@ -9332,22 +9509,22 @@
         <p:spPr>
           <a:xfrm>
             <a:off x="731520" y="2194560"/>
-            <a:ext cx="5029200" cy="2103120"/>
-          </a:xfrm>
-          <a:prstGeom prst="rect">
-            <a:avLst/>
-          </a:prstGeom>
-          <a:noFill/>
-        </p:spPr>
-        <p:txBody>
-          <a:bodyPr wrap="square" anchor="t" lIns="50800" rIns="50800" tIns="25400" bIns="25400">
-            <a:spAutoFit/>
-          </a:bodyPr>
-          <a:lstStyle/>
-          <a:p>
-            <a:pPr algn="l"/>
-            <a:r>
-              <a:rPr sz="1300" b="1" i="0">
+            <a:ext cx="5029200" cy="1020792"/>
+          </a:xfrm>
+          <a:prstGeom prst="rect">
+            <a:avLst/>
+          </a:prstGeom>
+          <a:noFill/>
+        </p:spPr>
+        <p:txBody>
+          <a:bodyPr wrap="square" lIns="50800" tIns="25400" rIns="50800" bIns="25400" anchor="t">
+            <a:spAutoFit/>
+          </a:bodyPr>
+          <a:lstStyle/>
+          <a:p>
+            <a:pPr algn="l"/>
+            <a:r>
+              <a:rPr sz="1300" b="1" i="0" dirty="0">
                 <a:solidFill>
                   <a:srgbClr val="2E6DB4"/>
                 </a:solidFill>
@@ -9359,7 +9536,7 @@
           <a:p>
             <a:pPr algn="l"/>
             <a:r>
-              <a:rPr sz="1200" b="0" i="1">
+              <a:rPr sz="1200" b="0" i="1" dirty="0">
                 <a:solidFill>
                   <a:srgbClr val="6B7280"/>
                 </a:solidFill>
@@ -9370,26 +9547,41 @@
           </a:p>
           <a:p>
             <a:pPr algn="l"/>
-            <a:r>
-              <a:rPr sz="600" b="0" i="0">
+            <a:endParaRPr sz="1200" b="0" i="1" dirty="0">
+              <a:solidFill>
+                <a:srgbClr val="6B7280"/>
+              </a:solidFill>
+              <a:latin typeface="Segoe UI"/>
+            </a:endParaRPr>
+          </a:p>
+          <a:p>
+            <a:pPr algn="l"/>
+            <a:r>
+              <a:rPr sz="1300" b="0" i="0" dirty="0">
                 <a:solidFill>
                   <a:srgbClr val="2D2D2D"/>
                 </a:solidFill>
                 <a:latin typeface="Segoe UI"/>
               </a:rPr>
-              <a:t/>
-            </a:r>
-          </a:p>
-          <a:p>
-            <a:pPr algn="l"/>
-            <a:r>
-              <a:rPr sz="1300" b="0" i="0">
+              <a:t>Sprint 2.4 closed Jul 7</a:t>
+            </a:r>
+            <a:r>
+              <a:rPr lang="en-US" sz="1300" b="0" i="0" dirty="0">
                 <a:solidFill>
                   <a:srgbClr val="2D2D2D"/>
                 </a:solidFill>
                 <a:latin typeface="Segoe UI"/>
               </a:rPr>
-              <a:t>Sprint 2.4 closed Jul 7 (9 items / 10 pts); CO5 acceptance gate = Data Dictionary CCB approval Jul 21</a:t>
+              <a:t>; </a:t>
+            </a:r>
+            <a:r>
+              <a:rPr sz="1300" b="0" i="0" dirty="0">
+                <a:solidFill>
+                  <a:srgbClr val="2D2D2D"/>
+                </a:solidFill>
+                <a:latin typeface="Segoe UI"/>
+              </a:rPr>
+              <a:t>CO5 acceptance gate = Data Dictionary CCB approval Jul 21</a:t>
             </a:r>
           </a:p>
         </p:txBody>
@@ -9435,6 +9627,7 @@
           <a:lstStyle/>
           <a:p>
             <a:pPr algn="ctr"/>
+            <a:endParaRPr/>
           </a:p>
         </p:txBody>
       </p:sp>
@@ -9479,6 +9672,7 @@
           <a:lstStyle/>
           <a:p>
             <a:pPr algn="ctr"/>
+            <a:endParaRPr/>
           </a:p>
         </p:txBody>
       </p:sp>
@@ -9499,7 +9693,7 @@
           <a:noFill/>
         </p:spPr>
         <p:txBody>
-          <a:bodyPr wrap="square" anchor="ctr" lIns="50800" rIns="50800" tIns="25400" bIns="25400">
+          <a:bodyPr wrap="square" lIns="50800" tIns="25400" rIns="50800" bIns="25400" anchor="ctr">
             <a:spAutoFit/>
           </a:bodyPr>
           <a:lstStyle/>
@@ -9534,7 +9728,7 @@
           <a:noFill/>
         </p:spPr>
         <p:txBody>
-          <a:bodyPr wrap="square" anchor="t" lIns="50800" rIns="50800" tIns="25400" bIns="25400">
+          <a:bodyPr wrap="square" lIns="50800" tIns="25400" rIns="50800" bIns="25400" anchor="t">
             <a:spAutoFit/>
           </a:bodyPr>
           <a:lstStyle/>
@@ -9564,15 +9758,12 @@
           </a:p>
           <a:p>
             <a:pPr algn="l"/>
-            <a:r>
-              <a:rPr sz="600" b="0" i="0">
-                <a:solidFill>
-                  <a:srgbClr val="2D2D2D"/>
-                </a:solidFill>
-                <a:latin typeface="Segoe UI"/>
-              </a:rPr>
-              <a:t/>
-            </a:r>
+            <a:endParaRPr sz="1200" b="0" i="1">
+              <a:solidFill>
+                <a:srgbClr val="6B7280"/>
+              </a:solidFill>
+              <a:latin typeface="Segoe UI"/>
+            </a:endParaRPr>
           </a:p>
           <a:p>
             <a:pPr algn="l"/>
@@ -9629,6 +9820,7 @@
           <a:lstStyle/>
           <a:p>
             <a:pPr algn="ctr"/>
+            <a:endParaRPr/>
           </a:p>
         </p:txBody>
       </p:sp>
@@ -9673,6 +9865,7 @@
           <a:lstStyle/>
           <a:p>
             <a:pPr algn="ctr"/>
+            <a:endParaRPr/>
           </a:p>
         </p:txBody>
       </p:sp>
@@ -9713,7 +9906,7 @@
           </a:fontRef>
         </p:style>
         <p:txBody>
-          <a:bodyPr rtlCol="0" anchor="ctr" wrap="none"/>
+          <a:bodyPr wrap="none" rtlCol="0" anchor="ctr"/>
           <a:lstStyle/>
           <a:p>
             <a:pPr algn="ctr"/>
@@ -9746,7 +9939,7 @@
           <a:noFill/>
         </p:spPr>
         <p:txBody>
-          <a:bodyPr wrap="square" anchor="ctr" lIns="50800" rIns="50800" tIns="25400" bIns="25400">
+          <a:bodyPr wrap="square" lIns="50800" tIns="25400" rIns="50800" bIns="25400" anchor="ctr">
             <a:spAutoFit/>
           </a:bodyPr>
           <a:lstStyle/>
@@ -9781,7 +9974,7 @@
           <a:noFill/>
         </p:spPr>
         <p:txBody>
-          <a:bodyPr wrap="square" anchor="t" lIns="50800" rIns="50800" tIns="25400" bIns="25400">
+          <a:bodyPr wrap="square" lIns="50800" tIns="25400" rIns="50800" bIns="25400" anchor="t">
             <a:spAutoFit/>
           </a:bodyPr>
           <a:lstStyle/>
@@ -9816,7 +10009,7 @@
           <a:noFill/>
         </p:spPr>
         <p:txBody>
-          <a:bodyPr wrap="square" anchor="t" lIns="50800" rIns="50800" tIns="25400" bIns="25400">
+          <a:bodyPr wrap="square" lIns="50800" tIns="25400" rIns="50800" bIns="25400" anchor="t">
             <a:spAutoFit/>
           </a:bodyPr>
           <a:lstStyle/>
@@ -9843,7 +10036,7 @@
 </file>
 
 <file path=ppt/slides/slide6.xml><?xml version="1.0" encoding="utf-8"?>
-<p:sld xmlns:a="http://schemas.openxmlformats.org/drawingml/2006/main" xmlns:p="http://schemas.openxmlformats.org/presentationml/2006/main" xmlns:r="http://schemas.openxmlformats.org/officeDocument/2006/relationships">
+<p:sld xmlns:a="http://schemas.openxmlformats.org/drawingml/2006/main" xmlns:r="http://schemas.openxmlformats.org/officeDocument/2006/relationships" xmlns:p="http://schemas.openxmlformats.org/presentationml/2006/main">
   <p:cSld>
     <p:spTree>
       <p:nvGrpSpPr>
@@ -9851,7 +10044,14 @@
         <p:cNvGrpSpPr/>
         <p:nvPr/>
       </p:nvGrpSpPr>
-      <p:grpSpPr/>
+      <p:grpSpPr>
+        <a:xfrm>
+          <a:off x="0" y="0"/>
+          <a:ext cx="0" cy="0"/>
+          <a:chOff x="0" y="0"/>
+          <a:chExt cx="0" cy="0"/>
+        </a:xfrm>
+      </p:grpSpPr>
       <p:sp>
         <p:nvSpPr>
           <p:cNvPr id="2" name="Rectangle 1"/>
@@ -9893,6 +10093,7 @@
           <a:lstStyle/>
           <a:p>
             <a:pPr algn="ctr"/>
+            <a:endParaRPr/>
           </a:p>
         </p:txBody>
       </p:sp>
@@ -9937,6 +10138,7 @@
           <a:lstStyle/>
           <a:p>
             <a:pPr algn="ctr"/>
+            <a:endParaRPr/>
           </a:p>
         </p:txBody>
       </p:sp>
@@ -9957,7 +10159,7 @@
           <a:noFill/>
         </p:spPr>
         <p:txBody>
-          <a:bodyPr wrap="square" anchor="ctr" lIns="50800" rIns="50800" tIns="25400" bIns="25400">
+          <a:bodyPr wrap="square" lIns="50800" tIns="25400" rIns="50800" bIns="25400" anchor="ctr">
             <a:spAutoFit/>
           </a:bodyPr>
           <a:lstStyle/>
@@ -9992,7 +10194,7 @@
           <a:noFill/>
         </p:spPr>
         <p:txBody>
-          <a:bodyPr wrap="square" anchor="ctr" lIns="50800" rIns="50800" tIns="25400" bIns="25400">
+          <a:bodyPr wrap="square" lIns="50800" tIns="25400" rIns="50800" bIns="25400" anchor="ctr">
             <a:spAutoFit/>
           </a:bodyPr>
           <a:lstStyle/>
@@ -10027,7 +10229,7 @@
           <a:noFill/>
         </p:spPr>
         <p:txBody>
-          <a:bodyPr wrap="square" anchor="t" lIns="50800" rIns="50800" tIns="25400" bIns="25400">
+          <a:bodyPr wrap="square" lIns="50800" tIns="25400" rIns="50800" bIns="25400" anchor="t">
             <a:spAutoFit/>
           </a:bodyPr>
           <a:lstStyle/>
@@ -10086,6 +10288,7 @@
           <a:lstStyle/>
           <a:p>
             <a:pPr algn="ctr"/>
+            <a:endParaRPr/>
           </a:p>
         </p:txBody>
       </p:sp>
@@ -10106,7 +10309,7 @@
           <a:noFill/>
         </p:spPr>
         <p:txBody>
-          <a:bodyPr wrap="square" anchor="ctr" lIns="50800" rIns="50800" tIns="25400" bIns="25400">
+          <a:bodyPr wrap="square" lIns="50800" tIns="25400" rIns="50800" bIns="25400" anchor="ctr">
             <a:spAutoFit/>
           </a:bodyPr>
           <a:lstStyle/>
@@ -10177,6 +10380,7 @@
           <a:lstStyle/>
           <a:p>
             <a:pPr algn="ctr"/>
+            <a:endParaRPr/>
           </a:p>
         </p:txBody>
       </p:sp>
@@ -10197,7 +10401,7 @@
           <a:noFill/>
         </p:spPr>
         <p:txBody>
-          <a:bodyPr wrap="square" anchor="t" lIns="50800" rIns="50800" tIns="25400" bIns="25400">
+          <a:bodyPr wrap="square" lIns="50800" tIns="25400" rIns="50800" bIns="25400" anchor="t">
             <a:spAutoFit/>
           </a:bodyPr>
           <a:lstStyle/>
@@ -10232,7 +10436,7 @@
           <a:noFill/>
         </p:spPr>
         <p:txBody>
-          <a:bodyPr wrap="square" anchor="t" lIns="50800" rIns="50800" tIns="25400" bIns="25400">
+          <a:bodyPr wrap="square" lIns="50800" tIns="25400" rIns="50800" bIns="25400" anchor="t">
             <a:spAutoFit/>
           </a:bodyPr>
           <a:lstStyle/>
@@ -10267,7 +10471,7 @@
           <a:noFill/>
         </p:spPr>
         <p:txBody>
-          <a:bodyPr wrap="square" anchor="t" lIns="50800" rIns="50800" tIns="25400" bIns="25400">
+          <a:bodyPr wrap="square" lIns="50800" tIns="25400" rIns="50800" bIns="25400" anchor="t">
             <a:spAutoFit/>
           </a:bodyPr>
           <a:lstStyle/>
@@ -10302,7 +10506,7 @@
           <a:noFill/>
         </p:spPr>
         <p:txBody>
-          <a:bodyPr wrap="square" anchor="t" lIns="50800" rIns="50800" tIns="25400" bIns="25400">
+          <a:bodyPr wrap="square" lIns="50800" tIns="25400" rIns="50800" bIns="25400" anchor="t">
             <a:spAutoFit/>
           </a:bodyPr>
           <a:lstStyle/>
@@ -10361,6 +10565,7 @@
           <a:lstStyle/>
           <a:p>
             <a:pPr algn="ctr"/>
+            <a:endParaRPr/>
           </a:p>
         </p:txBody>
       </p:sp>
@@ -10381,7 +10586,7 @@
           <a:noFill/>
         </p:spPr>
         <p:txBody>
-          <a:bodyPr wrap="square" anchor="ctr" lIns="50800" rIns="50800" tIns="25400" bIns="25400">
+          <a:bodyPr wrap="square" lIns="50800" tIns="25400" rIns="50800" bIns="25400" anchor="ctr">
             <a:spAutoFit/>
           </a:bodyPr>
           <a:lstStyle/>
@@ -10452,6 +10657,7 @@
           <a:lstStyle/>
           <a:p>
             <a:pPr algn="ctr"/>
+            <a:endParaRPr/>
           </a:p>
         </p:txBody>
       </p:sp>
@@ -10472,7 +10678,7 @@
           <a:noFill/>
         </p:spPr>
         <p:txBody>
-          <a:bodyPr wrap="square" anchor="t" lIns="50800" rIns="50800" tIns="25400" bIns="25400">
+          <a:bodyPr wrap="square" lIns="50800" tIns="25400" rIns="50800" bIns="25400" anchor="t">
             <a:spAutoFit/>
           </a:bodyPr>
           <a:lstStyle/>
@@ -10507,7 +10713,7 @@
           <a:noFill/>
         </p:spPr>
         <p:txBody>
-          <a:bodyPr wrap="square" anchor="t" lIns="50800" rIns="50800" tIns="25400" bIns="25400">
+          <a:bodyPr wrap="square" lIns="50800" tIns="25400" rIns="50800" bIns="25400" anchor="t">
             <a:spAutoFit/>
           </a:bodyPr>
           <a:lstStyle/>
@@ -10542,7 +10748,7 @@
           <a:noFill/>
         </p:spPr>
         <p:txBody>
-          <a:bodyPr wrap="square" anchor="t" lIns="50800" rIns="50800" tIns="25400" bIns="25400">
+          <a:bodyPr wrap="square" lIns="50800" tIns="25400" rIns="50800" bIns="25400" anchor="t">
             <a:spAutoFit/>
           </a:bodyPr>
           <a:lstStyle/>
@@ -10577,7 +10783,7 @@
           <a:noFill/>
         </p:spPr>
         <p:txBody>
-          <a:bodyPr wrap="square" anchor="t" lIns="50800" rIns="50800" tIns="25400" bIns="25400">
+          <a:bodyPr wrap="square" lIns="50800" tIns="25400" rIns="50800" bIns="25400" anchor="t">
             <a:spAutoFit/>
           </a:bodyPr>
           <a:lstStyle/>
@@ -10612,7 +10818,7 @@
           <a:noFill/>
         </p:spPr>
         <p:txBody>
-          <a:bodyPr wrap="square" anchor="t" lIns="50800" rIns="50800" tIns="25400" bIns="25400">
+          <a:bodyPr wrap="square" lIns="50800" tIns="25400" rIns="50800" bIns="25400" anchor="t">
             <a:spAutoFit/>
           </a:bodyPr>
           <a:lstStyle/>
@@ -10671,6 +10877,7 @@
           <a:lstStyle/>
           <a:p>
             <a:pPr algn="ctr"/>
+            <a:endParaRPr/>
           </a:p>
         </p:txBody>
       </p:sp>
@@ -10691,7 +10898,7 @@
           <a:noFill/>
         </p:spPr>
         <p:txBody>
-          <a:bodyPr wrap="square" anchor="ctr" lIns="50800" rIns="50800" tIns="25400" bIns="25400">
+          <a:bodyPr wrap="square" lIns="50800" tIns="25400" rIns="50800" bIns="25400" anchor="ctr">
             <a:spAutoFit/>
           </a:bodyPr>
           <a:lstStyle/>
@@ -10762,6 +10969,7 @@
           <a:lstStyle/>
           <a:p>
             <a:pPr algn="ctr"/>
+            <a:endParaRPr/>
           </a:p>
         </p:txBody>
       </p:sp>
@@ -10782,7 +10990,7 @@
           <a:noFill/>
         </p:spPr>
         <p:txBody>
-          <a:bodyPr wrap="square" anchor="t" lIns="50800" rIns="50800" tIns="25400" bIns="25400">
+          <a:bodyPr wrap="square" lIns="50800" tIns="25400" rIns="50800" bIns="25400" anchor="t">
             <a:spAutoFit/>
           </a:bodyPr>
           <a:lstStyle/>
@@ -10817,7 +11025,7 @@
           <a:noFill/>
         </p:spPr>
         <p:txBody>
-          <a:bodyPr wrap="square" anchor="t" lIns="50800" rIns="50800" tIns="25400" bIns="25400">
+          <a:bodyPr wrap="square" lIns="50800" tIns="25400" rIns="50800" bIns="25400" anchor="t">
             <a:spAutoFit/>
           </a:bodyPr>
           <a:lstStyle/>
@@ -10852,7 +11060,7 @@
           <a:noFill/>
         </p:spPr>
         <p:txBody>
-          <a:bodyPr wrap="square" anchor="t" lIns="50800" rIns="50800" tIns="25400" bIns="25400">
+          <a:bodyPr wrap="square" lIns="50800" tIns="25400" rIns="50800" bIns="25400" anchor="t">
             <a:spAutoFit/>
           </a:bodyPr>
           <a:lstStyle/>
@@ -10887,7 +11095,7 @@
           <a:noFill/>
         </p:spPr>
         <p:txBody>
-          <a:bodyPr wrap="square" anchor="t" lIns="50800" rIns="50800" tIns="25400" bIns="25400">
+          <a:bodyPr wrap="square" lIns="50800" tIns="25400" rIns="50800" bIns="25400" anchor="t">
             <a:spAutoFit/>
           </a:bodyPr>
           <a:lstStyle/>
@@ -10922,7 +11130,7 @@
           <a:noFill/>
         </p:spPr>
         <p:txBody>
-          <a:bodyPr wrap="square" anchor="t" lIns="50800" rIns="50800" tIns="25400" bIns="25400">
+          <a:bodyPr wrap="square" lIns="50800" tIns="25400" rIns="50800" bIns="25400" anchor="t">
             <a:spAutoFit/>
           </a:bodyPr>
           <a:lstStyle/>
@@ -10957,7 +11165,7 @@
           <a:noFill/>
         </p:spPr>
         <p:txBody>
-          <a:bodyPr wrap="square" anchor="t" lIns="50800" rIns="50800" tIns="25400" bIns="25400">
+          <a:bodyPr wrap="square" lIns="50800" tIns="25400" rIns="50800" bIns="25400" anchor="t">
             <a:spAutoFit/>
           </a:bodyPr>
           <a:lstStyle/>
@@ -11016,6 +11224,7 @@
           <a:lstStyle/>
           <a:p>
             <a:pPr algn="ctr"/>
+            <a:endParaRPr/>
           </a:p>
         </p:txBody>
       </p:sp>
@@ -11060,6 +11269,7 @@
           <a:lstStyle/>
           <a:p>
             <a:pPr algn="ctr"/>
+            <a:endParaRPr/>
           </a:p>
         </p:txBody>
       </p:sp>
@@ -11080,7 +11290,7 @@
           <a:noFill/>
         </p:spPr>
         <p:txBody>
-          <a:bodyPr wrap="square" anchor="t" lIns="50800" rIns="50800" tIns="25400" bIns="25400">
+          <a:bodyPr wrap="square" lIns="50800" tIns="25400" rIns="50800" bIns="25400" anchor="t">
             <a:spAutoFit/>
           </a:bodyPr>
           <a:lstStyle/>
@@ -11115,7 +11325,7 @@
           <a:noFill/>
         </p:spPr>
         <p:txBody>
-          <a:bodyPr wrap="square" anchor="t" lIns="50800" rIns="50800" tIns="25400" bIns="25400">
+          <a:bodyPr wrap="square" lIns="50800" tIns="25400" rIns="50800" bIns="25400" anchor="t">
             <a:spAutoFit/>
           </a:bodyPr>
           <a:lstStyle/>
@@ -11174,6 +11384,7 @@
           <a:lstStyle/>
           <a:p>
             <a:pPr algn="ctr"/>
+            <a:endParaRPr/>
           </a:p>
         </p:txBody>
       </p:sp>
@@ -11218,6 +11429,7 @@
           <a:lstStyle/>
           <a:p>
             <a:pPr algn="ctr"/>
+            <a:endParaRPr/>
           </a:p>
         </p:txBody>
       </p:sp>
@@ -11238,7 +11450,7 @@
           <a:noFill/>
         </p:spPr>
         <p:txBody>
-          <a:bodyPr wrap="square" anchor="t" lIns="50800" rIns="50800" tIns="25400" bIns="25400">
+          <a:bodyPr wrap="square" lIns="50800" tIns="25400" rIns="50800" bIns="25400" anchor="t">
             <a:spAutoFit/>
           </a:bodyPr>
           <a:lstStyle/>
@@ -11273,7 +11485,7 @@
           <a:noFill/>
         </p:spPr>
         <p:txBody>
-          <a:bodyPr wrap="square" anchor="t" lIns="50800" rIns="50800" tIns="25400" bIns="25400">
+          <a:bodyPr wrap="square" lIns="50800" tIns="25400" rIns="50800" bIns="25400" anchor="t">
             <a:spAutoFit/>
           </a:bodyPr>
           <a:lstStyle/>
@@ -11332,6 +11544,7 @@
           <a:lstStyle/>
           <a:p>
             <a:pPr algn="ctr"/>
+            <a:endParaRPr/>
           </a:p>
         </p:txBody>
       </p:sp>
@@ -11376,6 +11589,7 @@
           <a:lstStyle/>
           <a:p>
             <a:pPr algn="ctr"/>
+            <a:endParaRPr/>
           </a:p>
         </p:txBody>
       </p:sp>
@@ -11396,7 +11610,7 @@
           <a:noFill/>
         </p:spPr>
         <p:txBody>
-          <a:bodyPr wrap="square" anchor="t" lIns="50800" rIns="50800" tIns="25400" bIns="25400">
+          <a:bodyPr wrap="square" lIns="50800" tIns="25400" rIns="50800" bIns="25400" anchor="t">
             <a:spAutoFit/>
           </a:bodyPr>
           <a:lstStyle/>
@@ -11431,14 +11645,14 @@
           <a:noFill/>
         </p:spPr>
         <p:txBody>
-          <a:bodyPr wrap="square" anchor="t" lIns="50800" rIns="50800" tIns="25400" bIns="25400">
-            <a:spAutoFit/>
-          </a:bodyPr>
-          <a:lstStyle/>
-          <a:p>
-            <a:pPr algn="l"/>
-            <a:r>
-              <a:rPr sz="1500" b="1" i="0">
+          <a:bodyPr wrap="square" lIns="50800" tIns="25400" rIns="50800" bIns="25400" anchor="t">
+            <a:spAutoFit/>
+          </a:bodyPr>
+          <a:lstStyle/>
+          <a:p>
+            <a:pPr algn="l"/>
+            <a:r>
+              <a:rPr sz="1500" b="1" i="0" dirty="0">
                 <a:solidFill>
                   <a:srgbClr val="1F3A5F"/>
                 </a:solidFill>
@@ -11490,6 +11704,7 @@
           <a:lstStyle/>
           <a:p>
             <a:pPr algn="ctr"/>
+            <a:endParaRPr/>
           </a:p>
         </p:txBody>
       </p:sp>
@@ -11534,6 +11749,7 @@
           <a:lstStyle/>
           <a:p>
             <a:pPr algn="ctr"/>
+            <a:endParaRPr/>
           </a:p>
         </p:txBody>
       </p:sp>
@@ -11554,7 +11770,7 @@
           <a:noFill/>
         </p:spPr>
         <p:txBody>
-          <a:bodyPr wrap="square" anchor="t" lIns="50800" rIns="50800" tIns="25400" bIns="25400">
+          <a:bodyPr wrap="square" lIns="50800" tIns="25400" rIns="50800" bIns="25400" anchor="t">
             <a:spAutoFit/>
           </a:bodyPr>
           <a:lstStyle/>
@@ -11589,14 +11805,14 @@
           <a:noFill/>
         </p:spPr>
         <p:txBody>
-          <a:bodyPr wrap="square" anchor="t" lIns="50800" rIns="50800" tIns="25400" bIns="25400">
-            <a:spAutoFit/>
-          </a:bodyPr>
-          <a:lstStyle/>
-          <a:p>
-            <a:pPr algn="l"/>
-            <a:r>
-              <a:rPr sz="1500" b="1" i="0">
+          <a:bodyPr wrap="square" lIns="50800" tIns="25400" rIns="50800" bIns="25400" anchor="t">
+            <a:spAutoFit/>
+          </a:bodyPr>
+          <a:lstStyle/>
+          <a:p>
+            <a:pPr algn="l"/>
+            <a:r>
+              <a:rPr sz="1500" b="1" i="0" dirty="0">
                 <a:solidFill>
                   <a:srgbClr val="1F3A5F"/>
                 </a:solidFill>
@@ -11624,7 +11840,7 @@
           <a:noFill/>
         </p:spPr>
         <p:txBody>
-          <a:bodyPr wrap="square" anchor="t" lIns="50800" rIns="50800" tIns="25400" bIns="25400">
+          <a:bodyPr wrap="square" lIns="50800" tIns="25400" rIns="50800" bIns="25400" anchor="t">
             <a:spAutoFit/>
           </a:bodyPr>
           <a:lstStyle/>
@@ -11651,7 +11867,7 @@
 </file>
 
 <file path=ppt/slides/slide7.xml><?xml version="1.0" encoding="utf-8"?>
-<p:sld xmlns:a="http://schemas.openxmlformats.org/drawingml/2006/main" xmlns:p="http://schemas.openxmlformats.org/presentationml/2006/main" xmlns:r="http://schemas.openxmlformats.org/officeDocument/2006/relationships">
+<p:sld xmlns:a="http://schemas.openxmlformats.org/drawingml/2006/main" xmlns:r="http://schemas.openxmlformats.org/officeDocument/2006/relationships" xmlns:p="http://schemas.openxmlformats.org/presentationml/2006/main">
   <p:cSld>
     <p:spTree>
       <p:nvGrpSpPr>
@@ -11659,7 +11875,14 @@
         <p:cNvGrpSpPr/>
         <p:nvPr/>
       </p:nvGrpSpPr>
-      <p:grpSpPr/>
+      <p:grpSpPr>
+        <a:xfrm>
+          <a:off x="0" y="0"/>
+          <a:ext cx="0" cy="0"/>
+          <a:chOff x="0" y="0"/>
+          <a:chExt cx="0" cy="0"/>
+        </a:xfrm>
+      </p:grpSpPr>
       <p:sp>
         <p:nvSpPr>
           <p:cNvPr id="2" name="Rectangle 1"/>
@@ -11701,6 +11924,7 @@
           <a:lstStyle/>
           <a:p>
             <a:pPr algn="ctr"/>
+            <a:endParaRPr/>
           </a:p>
         </p:txBody>
       </p:sp>
@@ -11745,6 +11969,7 @@
           <a:lstStyle/>
           <a:p>
             <a:pPr algn="ctr"/>
+            <a:endParaRPr/>
           </a:p>
         </p:txBody>
       </p:sp>
@@ -11765,7 +11990,7 @@
           <a:noFill/>
         </p:spPr>
         <p:txBody>
-          <a:bodyPr wrap="square" anchor="ctr" lIns="50800" rIns="50800" tIns="25400" bIns="25400">
+          <a:bodyPr wrap="square" lIns="50800" tIns="25400" rIns="50800" bIns="25400" anchor="ctr">
             <a:spAutoFit/>
           </a:bodyPr>
           <a:lstStyle/>
@@ -11800,7 +12025,7 @@
           <a:noFill/>
         </p:spPr>
         <p:txBody>
-          <a:bodyPr wrap="square" anchor="ctr" lIns="50800" rIns="50800" tIns="25400" bIns="25400">
+          <a:bodyPr wrap="square" lIns="50800" tIns="25400" rIns="50800" bIns="25400" anchor="ctr">
             <a:spAutoFit/>
           </a:bodyPr>
           <a:lstStyle/>
@@ -11835,7 +12060,7 @@
           <a:noFill/>
         </p:spPr>
         <p:txBody>
-          <a:bodyPr wrap="square" anchor="t" lIns="50800" rIns="50800" tIns="25400" bIns="25400">
+          <a:bodyPr wrap="square" lIns="50800" tIns="25400" rIns="50800" bIns="25400" anchor="t">
             <a:spAutoFit/>
           </a:bodyPr>
           <a:lstStyle/>
@@ -11870,7 +12095,7 @@
           <a:noFill/>
         </p:spPr>
         <p:txBody>
-          <a:bodyPr wrap="square" anchor="t" lIns="50800" rIns="50800" tIns="25400" bIns="25400">
+          <a:bodyPr wrap="square" lIns="50800" tIns="25400" rIns="50800" bIns="25400" anchor="t">
             <a:spAutoFit/>
           </a:bodyPr>
           <a:lstStyle/>
@@ -11905,7 +12130,7 @@
           <a:noFill/>
         </p:spPr>
         <p:txBody>
-          <a:bodyPr wrap="square" anchor="t" lIns="50800" rIns="50800" tIns="25400" bIns="25400">
+          <a:bodyPr wrap="square" lIns="50800" tIns="25400" rIns="50800" bIns="25400" anchor="t">
             <a:spAutoFit/>
           </a:bodyPr>
           <a:lstStyle/>
@@ -11964,6 +12189,7 @@
           <a:lstStyle/>
           <a:p>
             <a:pPr algn="ctr"/>
+            <a:endParaRPr/>
           </a:p>
         </p:txBody>
       </p:sp>
@@ -12008,6 +12234,7 @@
           <a:lstStyle/>
           <a:p>
             <a:pPr algn="ctr"/>
+            <a:endParaRPr/>
           </a:p>
         </p:txBody>
       </p:sp>
@@ -12028,7 +12255,7 @@
           <a:noFill/>
         </p:spPr>
         <p:txBody>
-          <a:bodyPr wrap="square" anchor="t" lIns="50800" rIns="50800" tIns="25400" bIns="25400">
+          <a:bodyPr wrap="square" lIns="50800" tIns="25400" rIns="50800" bIns="25400" anchor="t">
             <a:spAutoFit/>
           </a:bodyPr>
           <a:lstStyle/>
@@ -12063,7 +12290,7 @@
           <a:noFill/>
         </p:spPr>
         <p:txBody>
-          <a:bodyPr wrap="square" anchor="t" lIns="50800" rIns="50800" tIns="25400" bIns="25400">
+          <a:bodyPr wrap="square" lIns="50800" tIns="25400" rIns="50800" bIns="25400" anchor="t">
             <a:spAutoFit/>
           </a:bodyPr>
           <a:lstStyle/>
@@ -12122,6 +12349,7 @@
           <a:lstStyle/>
           <a:p>
             <a:pPr algn="ctr"/>
+            <a:endParaRPr/>
           </a:p>
         </p:txBody>
       </p:sp>
@@ -12166,6 +12394,7 @@
           <a:lstStyle/>
           <a:p>
             <a:pPr algn="ctr"/>
+            <a:endParaRPr/>
           </a:p>
         </p:txBody>
       </p:sp>
@@ -12186,7 +12415,7 @@
           <a:noFill/>
         </p:spPr>
         <p:txBody>
-          <a:bodyPr wrap="square" anchor="t" lIns="50800" rIns="50800" tIns="25400" bIns="25400">
+          <a:bodyPr wrap="square" lIns="50800" tIns="25400" rIns="50800" bIns="25400" anchor="t">
             <a:spAutoFit/>
           </a:bodyPr>
           <a:lstStyle/>
@@ -12221,7 +12450,7 @@
           <a:noFill/>
         </p:spPr>
         <p:txBody>
-          <a:bodyPr wrap="square" anchor="t" lIns="50800" rIns="50800" tIns="25400" bIns="25400">
+          <a:bodyPr wrap="square" lIns="50800" tIns="25400" rIns="50800" bIns="25400" anchor="t">
             <a:spAutoFit/>
           </a:bodyPr>
           <a:lstStyle/>
@@ -12280,6 +12509,7 @@
           <a:lstStyle/>
           <a:p>
             <a:pPr algn="ctr"/>
+            <a:endParaRPr/>
           </a:p>
         </p:txBody>
       </p:sp>
@@ -12324,6 +12554,7 @@
           <a:lstStyle/>
           <a:p>
             <a:pPr algn="ctr"/>
+            <a:endParaRPr/>
           </a:p>
         </p:txBody>
       </p:sp>
@@ -12344,7 +12575,7 @@
           <a:noFill/>
         </p:spPr>
         <p:txBody>
-          <a:bodyPr wrap="square" anchor="t" lIns="50800" rIns="50800" tIns="25400" bIns="25400">
+          <a:bodyPr wrap="square" lIns="50800" tIns="25400" rIns="50800" bIns="25400" anchor="t">
             <a:spAutoFit/>
           </a:bodyPr>
           <a:lstStyle/>
@@ -12379,7 +12610,7 @@
           <a:noFill/>
         </p:spPr>
         <p:txBody>
-          <a:bodyPr wrap="square" anchor="t" lIns="50800" rIns="50800" tIns="25400" bIns="25400">
+          <a:bodyPr wrap="square" lIns="50800" tIns="25400" rIns="50800" bIns="25400" anchor="t">
             <a:spAutoFit/>
           </a:bodyPr>
           <a:lstStyle/>
@@ -12438,6 +12669,7 @@
           <a:lstStyle/>
           <a:p>
             <a:pPr algn="ctr"/>
+            <a:endParaRPr/>
           </a:p>
         </p:txBody>
       </p:sp>
@@ -12482,6 +12714,7 @@
           <a:lstStyle/>
           <a:p>
             <a:pPr algn="ctr"/>
+            <a:endParaRPr/>
           </a:p>
         </p:txBody>
       </p:sp>
@@ -12502,7 +12735,7 @@
           <a:noFill/>
         </p:spPr>
         <p:txBody>
-          <a:bodyPr wrap="square" anchor="t" lIns="50800" rIns="50800" tIns="25400" bIns="25400">
+          <a:bodyPr wrap="square" lIns="50800" tIns="25400" rIns="50800" bIns="25400" anchor="t">
             <a:spAutoFit/>
           </a:bodyPr>
           <a:lstStyle/>
@@ -12537,7 +12770,7 @@
           <a:noFill/>
         </p:spPr>
         <p:txBody>
-          <a:bodyPr wrap="square" anchor="t" lIns="50800" rIns="50800" tIns="25400" bIns="25400">
+          <a:bodyPr wrap="square" lIns="50800" tIns="25400" rIns="50800" bIns="25400" anchor="t">
             <a:spAutoFit/>
           </a:bodyPr>
           <a:lstStyle/>
@@ -12572,7 +12805,7 @@
           <a:noFill/>
         </p:spPr>
         <p:txBody>
-          <a:bodyPr wrap="square" anchor="t" lIns="50800" rIns="50800" tIns="25400" bIns="25400">
+          <a:bodyPr wrap="square" lIns="50800" tIns="25400" rIns="50800" bIns="25400" anchor="t">
             <a:spAutoFit/>
           </a:bodyPr>
           <a:lstStyle/>
@@ -12599,28 +12832,46 @@
         <p:spPr>
           <a:xfrm>
             <a:off x="640080" y="3749039"/>
-            <a:ext cx="10972800" cy="457200"/>
-          </a:xfrm>
-          <a:prstGeom prst="rect">
-            <a:avLst/>
-          </a:prstGeom>
-          <a:noFill/>
-        </p:spPr>
-        <p:txBody>
-          <a:bodyPr wrap="square" anchor="t" lIns="50800" rIns="50800" tIns="25400" bIns="25400">
-            <a:spAutoFit/>
-          </a:bodyPr>
-          <a:lstStyle/>
-          <a:p>
-            <a:pPr algn="l"/>
-            <a:r>
-              <a:rPr sz="1150" b="0" i="0">
+            <a:ext cx="10972800" cy="228268"/>
+          </a:xfrm>
+          <a:prstGeom prst="rect">
+            <a:avLst/>
+          </a:prstGeom>
+          <a:noFill/>
+        </p:spPr>
+        <p:txBody>
+          <a:bodyPr wrap="square" lIns="50800" tIns="25400" rIns="50800" bIns="25400" anchor="t">
+            <a:spAutoFit/>
+          </a:bodyPr>
+          <a:lstStyle/>
+          <a:p>
+            <a:pPr algn="l"/>
+            <a:r>
+              <a:rPr sz="1150" b="0" i="0" dirty="0">
                 <a:solidFill>
                   <a:srgbClr val="2D2D2D"/>
                 </a:solidFill>
                 <a:latin typeface="Segoe UI"/>
               </a:rPr>
-              <a:t>+  Sprint 2.4 closed (Jul 7) - 9 items / 10 pts accepted: SOX BA review, Airlift exports (PA/KY VMware + PA Physical), bulk CI retirement, NowAssist Duplicate CIs, IRE review spike.</a:t>
+              <a:t>+  Sprint 2.4 closed (Jul 7: SOX BA review, Airlift exports (PA/KY VMware + PA Physical), bulk CI retirement, </a:t>
+            </a:r>
+            <a:r>
+              <a:rPr sz="1150" b="0" i="0" dirty="0" err="1">
+                <a:solidFill>
+                  <a:srgbClr val="2D2D2D"/>
+                </a:solidFill>
+                <a:latin typeface="Segoe UI"/>
+              </a:rPr>
+              <a:t>NowAssist</a:t>
+            </a:r>
+            <a:r>
+              <a:rPr sz="1150" b="0" i="0" dirty="0">
+                <a:solidFill>
+                  <a:srgbClr val="2D2D2D"/>
+                </a:solidFill>
+                <a:latin typeface="Segoe UI"/>
+              </a:rPr>
+              <a:t> Duplicate CIs, IRE review spike.</a:t>
             </a:r>
           </a:p>
         </p:txBody>
@@ -12642,7 +12893,7 @@
           <a:noFill/>
         </p:spPr>
         <p:txBody>
-          <a:bodyPr wrap="square" anchor="t" lIns="50800" rIns="50800" tIns="25400" bIns="25400">
+          <a:bodyPr wrap="square" lIns="50800" tIns="25400" rIns="50800" bIns="25400" anchor="t">
             <a:spAutoFit/>
           </a:bodyPr>
           <a:lstStyle/>
@@ -12677,7 +12928,7 @@
           <a:noFill/>
         </p:spPr>
         <p:txBody>
-          <a:bodyPr wrap="square" anchor="t" lIns="50800" rIns="50800" tIns="25400" bIns="25400">
+          <a:bodyPr wrap="square" lIns="50800" tIns="25400" rIns="50800" bIns="25400" anchor="t">
             <a:spAutoFit/>
           </a:bodyPr>
           <a:lstStyle/>
@@ -12712,7 +12963,7 @@
           <a:noFill/>
         </p:spPr>
         <p:txBody>
-          <a:bodyPr wrap="square" anchor="t" lIns="50800" rIns="50800" tIns="25400" bIns="25400">
+          <a:bodyPr wrap="square" lIns="50800" tIns="25400" rIns="50800" bIns="25400" anchor="t">
             <a:spAutoFit/>
           </a:bodyPr>
           <a:lstStyle/>
@@ -12747,7 +12998,7 @@
           <a:noFill/>
         </p:spPr>
         <p:txBody>
-          <a:bodyPr wrap="square" anchor="t" lIns="50800" rIns="50800" tIns="25400" bIns="25400">
+          <a:bodyPr wrap="square" lIns="50800" tIns="25400" rIns="50800" bIns="25400" anchor="t">
             <a:spAutoFit/>
           </a:bodyPr>
           <a:lstStyle/>
@@ -12774,7 +13025,7 @@
 </file>
 
 <file path=ppt/slides/slide8.xml><?xml version="1.0" encoding="utf-8"?>
-<p:sld xmlns:a="http://schemas.openxmlformats.org/drawingml/2006/main" xmlns:p="http://schemas.openxmlformats.org/presentationml/2006/main" xmlns:r="http://schemas.openxmlformats.org/officeDocument/2006/relationships">
+<p:sld xmlns:a="http://schemas.openxmlformats.org/drawingml/2006/main" xmlns:r="http://schemas.openxmlformats.org/officeDocument/2006/relationships" xmlns:p="http://schemas.openxmlformats.org/presentationml/2006/main">
   <p:cSld>
     <p:spTree>
       <p:nvGrpSpPr>
@@ -12782,7 +13033,14 @@
         <p:cNvGrpSpPr/>
         <p:nvPr/>
       </p:nvGrpSpPr>
-      <p:grpSpPr/>
+      <p:grpSpPr>
+        <a:xfrm>
+          <a:off x="0" y="0"/>
+          <a:ext cx="0" cy="0"/>
+          <a:chOff x="0" y="0"/>
+          <a:chExt cx="0" cy="0"/>
+        </a:xfrm>
+      </p:grpSpPr>
       <p:sp>
         <p:nvSpPr>
           <p:cNvPr id="2" name="Rectangle 1"/>
@@ -12824,6 +13082,7 @@
           <a:lstStyle/>
           <a:p>
             <a:pPr algn="ctr"/>
+            <a:endParaRPr/>
           </a:p>
         </p:txBody>
       </p:sp>
@@ -12868,6 +13127,7 @@
           <a:lstStyle/>
           <a:p>
             <a:pPr algn="ctr"/>
+            <a:endParaRPr/>
           </a:p>
         </p:txBody>
       </p:sp>
@@ -12888,7 +13148,7 @@
           <a:noFill/>
         </p:spPr>
         <p:txBody>
-          <a:bodyPr wrap="square" anchor="ctr" lIns="50800" rIns="50800" tIns="25400" bIns="25400">
+          <a:bodyPr wrap="square" lIns="50800" tIns="25400" rIns="50800" bIns="25400" anchor="ctr">
             <a:spAutoFit/>
           </a:bodyPr>
           <a:lstStyle/>
@@ -12923,7 +13183,7 @@
           <a:noFill/>
         </p:spPr>
         <p:txBody>
-          <a:bodyPr wrap="square" anchor="ctr" lIns="50800" rIns="50800" tIns="25400" bIns="25400">
+          <a:bodyPr wrap="square" lIns="50800" tIns="25400" rIns="50800" bIns="25400" anchor="ctr">
             <a:spAutoFit/>
           </a:bodyPr>
           <a:lstStyle/>
@@ -12958,7 +13218,7 @@
           <a:noFill/>
         </p:spPr>
         <p:txBody>
-          <a:bodyPr wrap="square" anchor="t" lIns="50800" rIns="50800" tIns="25400" bIns="25400">
+          <a:bodyPr wrap="square" lIns="50800" tIns="25400" rIns="50800" bIns="25400" anchor="t">
             <a:spAutoFit/>
           </a:bodyPr>
           <a:lstStyle/>
@@ -13017,6 +13277,7 @@
           <a:lstStyle/>
           <a:p>
             <a:pPr algn="ctr"/>
+            <a:endParaRPr/>
           </a:p>
         </p:txBody>
       </p:sp>
@@ -13057,7 +13318,7 @@
           </a:fontRef>
         </p:style>
         <p:txBody>
-          <a:bodyPr rtlCol="0" anchor="ctr" wrap="none"/>
+          <a:bodyPr wrap="none" rtlCol="0" anchor="ctr"/>
           <a:lstStyle/>
           <a:p>
             <a:pPr algn="ctr"/>
@@ -13090,7 +13351,7 @@
           <a:noFill/>
         </p:spPr>
         <p:txBody>
-          <a:bodyPr wrap="square" anchor="t" lIns="50800" rIns="50800" tIns="25400" bIns="25400">
+          <a:bodyPr wrap="square" lIns="50800" tIns="25400" rIns="50800" bIns="25400" anchor="t">
             <a:spAutoFit/>
           </a:bodyPr>
           <a:lstStyle/>
@@ -13125,7 +13386,7 @@
           <a:noFill/>
         </p:spPr>
         <p:txBody>
-          <a:bodyPr wrap="square" anchor="t" lIns="50800" rIns="50800" tIns="25400" bIns="25400">
+          <a:bodyPr wrap="square" lIns="50800" tIns="25400" rIns="50800" bIns="25400" anchor="t">
             <a:spAutoFit/>
           </a:bodyPr>
           <a:lstStyle/>
@@ -13184,6 +13445,7 @@
           <a:lstStyle/>
           <a:p>
             <a:pPr algn="ctr"/>
+            <a:endParaRPr/>
           </a:p>
         </p:txBody>
       </p:sp>
@@ -13224,7 +13486,7 @@
           </a:fontRef>
         </p:style>
         <p:txBody>
-          <a:bodyPr rtlCol="0" anchor="ctr" wrap="none"/>
+          <a:bodyPr wrap="none" rtlCol="0" anchor="ctr"/>
           <a:lstStyle/>
           <a:p>
             <a:pPr algn="ctr"/>
@@ -13257,7 +13519,7 @@
           <a:noFill/>
         </p:spPr>
         <p:txBody>
-          <a:bodyPr wrap="square" anchor="t" lIns="50800" rIns="50800" tIns="25400" bIns="25400">
+          <a:bodyPr wrap="square" lIns="50800" tIns="25400" rIns="50800" bIns="25400" anchor="t">
             <a:spAutoFit/>
           </a:bodyPr>
           <a:lstStyle/>
@@ -13292,7 +13554,7 @@
           <a:noFill/>
         </p:spPr>
         <p:txBody>
-          <a:bodyPr wrap="square" anchor="t" lIns="50800" rIns="50800" tIns="25400" bIns="25400">
+          <a:bodyPr wrap="square" lIns="50800" tIns="25400" rIns="50800" bIns="25400" anchor="t">
             <a:spAutoFit/>
           </a:bodyPr>
           <a:lstStyle/>
@@ -13351,6 +13613,7 @@
           <a:lstStyle/>
           <a:p>
             <a:pPr algn="ctr"/>
+            <a:endParaRPr/>
           </a:p>
         </p:txBody>
       </p:sp>
@@ -13391,7 +13654,7 @@
           </a:fontRef>
         </p:style>
         <p:txBody>
-          <a:bodyPr rtlCol="0" anchor="ctr" wrap="none"/>
+          <a:bodyPr wrap="none" rtlCol="0" anchor="ctr"/>
           <a:lstStyle/>
           <a:p>
             <a:pPr algn="ctr"/>
@@ -13424,7 +13687,7 @@
           <a:noFill/>
         </p:spPr>
         <p:txBody>
-          <a:bodyPr wrap="square" anchor="t" lIns="50800" rIns="50800" tIns="25400" bIns="25400">
+          <a:bodyPr wrap="square" lIns="50800" tIns="25400" rIns="50800" bIns="25400" anchor="t">
             <a:spAutoFit/>
           </a:bodyPr>
           <a:lstStyle/>
@@ -13459,7 +13722,7 @@
           <a:noFill/>
         </p:spPr>
         <p:txBody>
-          <a:bodyPr wrap="square" anchor="t" lIns="50800" rIns="50800" tIns="25400" bIns="25400">
+          <a:bodyPr wrap="square" lIns="50800" tIns="25400" rIns="50800" bIns="25400" anchor="t">
             <a:spAutoFit/>
           </a:bodyPr>
           <a:lstStyle/>
@@ -13486,7 +13749,7 @@
 </file>
 
 <file path=ppt/slides/slide9.xml><?xml version="1.0" encoding="utf-8"?>
-<p:sld xmlns:a="http://schemas.openxmlformats.org/drawingml/2006/main" xmlns:p="http://schemas.openxmlformats.org/presentationml/2006/main" xmlns:r="http://schemas.openxmlformats.org/officeDocument/2006/relationships">
+<p:sld xmlns:a="http://schemas.openxmlformats.org/drawingml/2006/main" xmlns:r="http://schemas.openxmlformats.org/officeDocument/2006/relationships" xmlns:p="http://schemas.openxmlformats.org/presentationml/2006/main">
   <p:cSld>
     <p:spTree>
       <p:nvGrpSpPr>
@@ -13494,7 +13757,14 @@
         <p:cNvGrpSpPr/>
         <p:nvPr/>
       </p:nvGrpSpPr>
-      <p:grpSpPr/>
+      <p:grpSpPr>
+        <a:xfrm>
+          <a:off x="0" y="0"/>
+          <a:ext cx="0" cy="0"/>
+          <a:chOff x="0" y="0"/>
+          <a:chExt cx="0" cy="0"/>
+        </a:xfrm>
+      </p:grpSpPr>
       <p:sp>
         <p:nvSpPr>
           <p:cNvPr id="2" name="Rectangle 1"/>
@@ -13536,6 +13806,7 @@
           <a:lstStyle/>
           <a:p>
             <a:pPr algn="ctr"/>
+            <a:endParaRPr/>
           </a:p>
         </p:txBody>
       </p:sp>
@@ -13580,6 +13851,7 @@
           <a:lstStyle/>
           <a:p>
             <a:pPr algn="ctr"/>
+            <a:endParaRPr/>
           </a:p>
         </p:txBody>
       </p:sp>
@@ -13600,7 +13872,7 @@
           <a:noFill/>
         </p:spPr>
         <p:txBody>
-          <a:bodyPr wrap="square" anchor="ctr" lIns="50800" rIns="50800" tIns="25400" bIns="25400">
+          <a:bodyPr wrap="square" lIns="50800" tIns="25400" rIns="50800" bIns="25400" anchor="ctr">
             <a:spAutoFit/>
           </a:bodyPr>
           <a:lstStyle/>
@@ -13635,7 +13907,7 @@
           <a:noFill/>
         </p:spPr>
         <p:txBody>
-          <a:bodyPr wrap="square" anchor="ctr" lIns="50800" rIns="50800" tIns="25400" bIns="25400">
+          <a:bodyPr wrap="square" lIns="50800" tIns="25400" rIns="50800" bIns="25400" anchor="ctr">
             <a:spAutoFit/>
           </a:bodyPr>
           <a:lstStyle/>
@@ -13670,7 +13942,7 @@
           <a:noFill/>
         </p:spPr>
         <p:txBody>
-          <a:bodyPr wrap="square" anchor="t" lIns="50800" rIns="50800" tIns="25400" bIns="25400">
+          <a:bodyPr wrap="square" lIns="50800" tIns="25400" rIns="50800" bIns="25400" anchor="t">
             <a:spAutoFit/>
           </a:bodyPr>
           <a:lstStyle/>
@@ -13729,6 +14001,7 @@
           <a:lstStyle/>
           <a:p>
             <a:pPr algn="ctr"/>
+            <a:endParaRPr/>
           </a:p>
         </p:txBody>
       </p:sp>
@@ -13769,7 +14042,7 @@
           </a:fontRef>
         </p:style>
         <p:txBody>
-          <a:bodyPr rtlCol="0" anchor="ctr" wrap="none"/>
+          <a:bodyPr wrap="none" rtlCol="0" anchor="ctr"/>
           <a:lstStyle/>
           <a:p>
             <a:pPr algn="ctr"/>
@@ -13802,7 +14075,7 @@
           <a:noFill/>
         </p:spPr>
         <p:txBody>
-          <a:bodyPr wrap="square" anchor="t" lIns="50800" rIns="50800" tIns="25400" bIns="25400">
+          <a:bodyPr wrap="square" lIns="50800" tIns="25400" rIns="50800" bIns="25400" anchor="t">
             <a:spAutoFit/>
           </a:bodyPr>
           <a:lstStyle/>
@@ -13837,7 +14110,7 @@
           <a:noFill/>
         </p:spPr>
         <p:txBody>
-          <a:bodyPr wrap="square" anchor="t" lIns="50800" rIns="50800" tIns="25400" bIns="25400">
+          <a:bodyPr wrap="square" lIns="50800" tIns="25400" rIns="50800" bIns="25400" anchor="t">
             <a:spAutoFit/>
           </a:bodyPr>
           <a:lstStyle/>
@@ -13896,6 +14169,7 @@
           <a:lstStyle/>
           <a:p>
             <a:pPr algn="ctr"/>
+            <a:endParaRPr/>
           </a:p>
         </p:txBody>
       </p:sp>
@@ -13936,7 +14210,7 @@
           </a:fontRef>
         </p:style>
         <p:txBody>
-          <a:bodyPr rtlCol="0" anchor="ctr" wrap="none"/>
+          <a:bodyPr wrap="none" rtlCol="0" anchor="ctr"/>
           <a:lstStyle/>
           <a:p>
             <a:pPr algn="ctr"/>
@@ -13969,7 +14243,7 @@
           <a:noFill/>
         </p:spPr>
         <p:txBody>
-          <a:bodyPr wrap="square" anchor="t" lIns="50800" rIns="50800" tIns="25400" bIns="25400">
+          <a:bodyPr wrap="square" lIns="50800" tIns="25400" rIns="50800" bIns="25400" anchor="t">
             <a:spAutoFit/>
           </a:bodyPr>
           <a:lstStyle/>
@@ -14004,7 +14278,7 @@
           <a:noFill/>
         </p:spPr>
         <p:txBody>
-          <a:bodyPr wrap="square" anchor="t" lIns="50800" rIns="50800" tIns="25400" bIns="25400">
+          <a:bodyPr wrap="square" lIns="50800" tIns="25400" rIns="50800" bIns="25400" anchor="t">
             <a:spAutoFit/>
           </a:bodyPr>
           <a:lstStyle/>
@@ -14063,6 +14337,7 @@
           <a:lstStyle/>
           <a:p>
             <a:pPr algn="ctr"/>
+            <a:endParaRPr/>
           </a:p>
         </p:txBody>
       </p:sp>
@@ -14103,7 +14378,7 @@
           </a:fontRef>
         </p:style>
         <p:txBody>
-          <a:bodyPr rtlCol="0" anchor="ctr" wrap="none"/>
+          <a:bodyPr wrap="none" rtlCol="0" anchor="ctr"/>
           <a:lstStyle/>
           <a:p>
             <a:pPr algn="ctr"/>
@@ -14136,7 +14411,7 @@
           <a:noFill/>
         </p:spPr>
         <p:txBody>
-          <a:bodyPr wrap="square" anchor="t" lIns="50800" rIns="50800" tIns="25400" bIns="25400">
+          <a:bodyPr wrap="square" lIns="50800" tIns="25400" rIns="50800" bIns="25400" anchor="t">
             <a:spAutoFit/>
           </a:bodyPr>
           <a:lstStyle/>
@@ -14171,7 +14446,7 @@
           <a:noFill/>
         </p:spPr>
         <p:txBody>
-          <a:bodyPr wrap="square" anchor="t" lIns="50800" rIns="50800" tIns="25400" bIns="25400">
+          <a:bodyPr wrap="square" lIns="50800" tIns="25400" rIns="50800" bIns="25400" anchor="t">
             <a:spAutoFit/>
           </a:bodyPr>
           <a:lstStyle/>

</xml_diff>